<commit_message>
chore(krava): update deck to the redone version + cache-bust the embed (?v=2)
Co-Authored-By: Claude Opus 4.8 <noreply@anthropic.com>
</commit_message>
<xml_diff>
--- a/public/krava/deck.pptx
+++ b/public/krava/deck.pptx
@@ -4,16 +4,16 @@
   <p:sldMasterIdLst>
     <p:sldMasterId id="2147483648" r:id="rId1"/>
   </p:sldMasterIdLst>
+  <p:notesMasterIdLst>
+    <p:notesMasterId r:id="rId6"/>
+  </p:notesMasterIdLst>
   <p:sldIdLst>
     <p:sldId id="256" r:id="rId2"/>
     <p:sldId id="257" r:id="rId3"/>
     <p:sldId id="258" r:id="rId4"/>
     <p:sldId id="259" r:id="rId5"/>
   </p:sldIdLst>
-  <p:notesMasterIdLst>
-    <p:notesMasterId r:id="rId6"/>
-  </p:notesMasterIdLst>
-  <p:sldSz cx="9144000" cy="5143500"/>
+  <p:sldSz cx="9144000" cy="5143500" type="screen16x9"/>
   <p:notesSz cx="5143500" cy="9144000"/>
   <p:defaultTextStyle>
     <a:lvl1pPr marL="0" algn="l" defTabSz="914400" rtl="0" eaLnBrk="1" latinLnBrk="0" hangingPunct="1">
@@ -107,6 +107,11 @@
       </a:defRPr>
     </a:lvl9pPr>
   </p:defaultTextStyle>
+  <p:extLst>
+    <p:ext uri="{EFAFB233-063F-42B5-8137-9DF3F51BA10A}">
+      <p15:sldGuideLst xmlns:p15="http://schemas.microsoft.com/office/powerpoint/2012/main"/>
+    </p:ext>
+  </p:extLst>
 </p:presentation>
 </file>
 
@@ -132,234 +137,10 @@
           <a:chExt cx="0" cy="0"/>
         </a:xfrm>
       </p:grpSpPr>
-      <p:sp>
-        <p:nvSpPr>
-          <p:cNvPr id="2" name="Header Placeholder 1"/>
-          <p:cNvSpPr>
-            <a:spLocks noGrp="1"/>
-          </p:cNvSpPr>
-          <p:nvPr>
-            <p:ph type="hdr" sz="quarter"/>
-          </p:nvPr>
-        </p:nvSpPr>
-        <p:spPr>
-          <a:xfrm>
-            <a:off x="0" y="0"/>
-            <a:ext cx="2971800" cy="458788"/>
-          </a:xfrm>
-          <a:prstGeom prst="rect">
-            <a:avLst/>
-          </a:prstGeom>
-        </p:spPr>
-        <p:txBody>
-          <a:bodyPr vert="horz" lIns="91440" tIns="45720" rIns="91440" bIns="45720" rtlCol="0"/>
-          <a:lstStyle>
-            <a:lvl1pPr algn="l">
-              <a:defRPr sz="1200"/>
-            </a:lvl1pPr>
-          </a:lstStyle>
-          <a:p>
-            <a:endParaRPr lang="en-US"/>
-          </a:p>
-        </p:txBody>
-      </p:sp>
-      <p:sp>
-        <p:nvSpPr>
-          <p:cNvPr id="3" name="Date Placeholder 2"/>
-          <p:cNvSpPr>
-            <a:spLocks noGrp="1"/>
-          </p:cNvSpPr>
-          <p:nvPr>
-            <p:ph type="dt" idx="1"/>
-          </p:nvPr>
-        </p:nvSpPr>
-        <p:spPr>
-          <a:xfrm>
-            <a:off x="3884613" y="0"/>
-            <a:ext cx="2971800" cy="458788"/>
-          </a:xfrm>
-          <a:prstGeom prst="rect">
-            <a:avLst/>
-          </a:prstGeom>
-        </p:spPr>
-        <p:txBody>
-          <a:bodyPr vert="horz" lIns="91440" tIns="45720" rIns="91440" bIns="45720" rtlCol="0"/>
-          <a:lstStyle>
-            <a:lvl1pPr algn="r">
-              <a:defRPr sz="1200"/>
-            </a:lvl1pPr>
-          </a:lstStyle>
-          <a:p>
-            <a:fld id="{5282F153-3F37-0F45-9E97-73ACFA13230C}" type="datetimeFigureOut">
-              <a:rPr lang="en-US"/>
-              <a:t>7/23/19</a:t>
-            </a:fld>
-            <a:endParaRPr lang="en-US"/>
-          </a:p>
-        </p:txBody>
-      </p:sp>
-      <p:sp>
-        <p:nvSpPr>
-          <p:cNvPr id="4" name="Slide Image Placeholder 3"/>
-          <p:cNvSpPr>
-            <a:spLocks noGrp="1" noRot="1" noChangeAspect="1"/>
-          </p:cNvSpPr>
-          <p:nvPr>
-            <p:ph type="sldImg" idx="2"/>
-          </p:nvPr>
-        </p:nvSpPr>
-        <p:spPr>
-          <a:xfrm>
-            <a:off x="685800" y="1143000"/>
-            <a:ext cx="5486400" cy="3086100"/>
-          </a:xfrm>
-          <a:prstGeom prst="rect">
-            <a:avLst/>
-          </a:prstGeom>
-          <a:noFill/>
-          <a:ln w="12700">
-            <a:solidFill>
-              <a:prstClr val="black"/>
-            </a:solidFill>
-          </a:ln>
-        </p:spPr>
-        <p:txBody>
-          <a:bodyPr vert="horz" lIns="91440" tIns="45720" rIns="91440" bIns="45720" rtlCol="0" anchor="ctr"/>
-          <a:lstStyle/>
-          <a:p>
-            <a:endParaRPr lang="en-US"/>
-          </a:p>
-        </p:txBody>
-      </p:sp>
-      <p:sp>
-        <p:nvSpPr>
-          <p:cNvPr id="5" name="Notes Placeholder 4"/>
-          <p:cNvSpPr>
-            <a:spLocks noGrp="1"/>
-          </p:cNvSpPr>
-          <p:nvPr>
-            <p:ph type="body" sz="quarter" idx="3"/>
-          </p:nvPr>
-        </p:nvSpPr>
-        <p:spPr>
-          <a:xfrm>
-            <a:off x="685800" y="4400550"/>
-            <a:ext cx="5486400" cy="3600450"/>
-          </a:xfrm>
-          <a:prstGeom prst="rect">
-            <a:avLst/>
-          </a:prstGeom>
-        </p:spPr>
-        <p:txBody>
-          <a:bodyPr vert="horz" lIns="91440" tIns="45720" rIns="91440" bIns="45720" rtlCol="0"/>
-          <a:lstStyle/>
-          <a:p>
-            <a:pPr lvl="0"/>
-            <a:r>
-              <a:rPr lang="en-US"/>
-              <a:t>Click to edit Master text styles</a:t>
-            </a:r>
-          </a:p>
-          <a:p>
-            <a:pPr lvl="1"/>
-            <a:r>
-              <a:rPr lang="en-US"/>
-              <a:t>Second level</a:t>
-            </a:r>
-          </a:p>
-          <a:p>
-            <a:pPr lvl="2"/>
-            <a:r>
-              <a:rPr lang="en-US"/>
-              <a:t>Third level</a:t>
-            </a:r>
-          </a:p>
-          <a:p>
-            <a:pPr lvl="3"/>
-            <a:r>
-              <a:rPr lang="en-US"/>
-              <a:t>Fourth level</a:t>
-            </a:r>
-          </a:p>
-          <a:p>
-            <a:pPr lvl="4"/>
-            <a:r>
-              <a:rPr lang="en-US"/>
-              <a:t>Fifth level</a:t>
-            </a:r>
-          </a:p>
-        </p:txBody>
-      </p:sp>
-      <p:sp>
-        <p:nvSpPr>
-          <p:cNvPr id="6" name="Footer Placeholder 5"/>
-          <p:cNvSpPr>
-            <a:spLocks noGrp="1"/>
-          </p:cNvSpPr>
-          <p:nvPr>
-            <p:ph type="ftr" sz="quarter" idx="4"/>
-          </p:nvPr>
-        </p:nvSpPr>
-        <p:spPr>
-          <a:xfrm>
-            <a:off x="0" y="8685213"/>
-            <a:ext cx="2971800" cy="458787"/>
-          </a:xfrm>
-          <a:prstGeom prst="rect">
-            <a:avLst/>
-          </a:prstGeom>
-        </p:spPr>
-        <p:txBody>
-          <a:bodyPr vert="horz" lIns="91440" tIns="45720" rIns="91440" bIns="45720" rtlCol="0" anchor="b"/>
-          <a:lstStyle>
-            <a:lvl1pPr algn="l">
-              <a:defRPr sz="1200"/>
-            </a:lvl1pPr>
-          </a:lstStyle>
-          <a:p>
-            <a:endParaRPr lang="en-US"/>
-          </a:p>
-        </p:txBody>
-      </p:sp>
-      <p:sp>
-        <p:nvSpPr>
-          <p:cNvPr id="7" name="Slide Number Placeholder 6"/>
-          <p:cNvSpPr>
-            <a:spLocks noGrp="1"/>
-          </p:cNvSpPr>
-          <p:nvPr>
-            <p:ph type="sldNum" sz="quarter" idx="5"/>
-          </p:nvPr>
-        </p:nvSpPr>
-        <p:spPr>
-          <a:xfrm>
-            <a:off x="3884613" y="8685213"/>
-            <a:ext cx="2971800" cy="458787"/>
-          </a:xfrm>
-          <a:prstGeom prst="rect">
-            <a:avLst/>
-          </a:prstGeom>
-        </p:spPr>
-        <p:txBody>
-          <a:bodyPr vert="horz" lIns="91440" tIns="45720" rIns="91440" bIns="45720" rtlCol="0" anchor="b"/>
-          <a:lstStyle>
-            <a:lvl1pPr algn="r">
-              <a:defRPr sz="1200"/>
-            </a:lvl1pPr>
-          </a:lstStyle>
-          <a:p>
-            <a:fld id="{CE5E9CC1-C706-0F49-92D6-E571CC5EEA8F}" type="slidenum">
-              <a:rPr lang="en-US"/>
-              <a:t>‹#›</a:t>
-            </a:fld>
-            <a:endParaRPr lang="en-US"/>
-          </a:p>
-        </p:txBody>
-      </p:sp>
     </p:spTree>
     <p:extLst>
       <p:ext uri="{BB962C8B-B14F-4D97-AF65-F5344CB8AC3E}">
-        <p14:creationId xmlns:p14="http://schemas.microsoft.com/office/powerpoint/2010/main" val="1024086991"/>
+        <p14:creationId xmlns:p14="http://schemas.microsoft.com/office/powerpoint/2010/main" val="681215192"/>
       </p:ext>
     </p:extLst>
   </p:cSld>
@@ -503,10 +284,6 @@
           <a:bodyPr/>
           <a:lstStyle/>
           <a:p>
-            <a:r>
-              <a:rPr lang="en-US" dirty="0"/>
-              <a:t/>
-            </a:r>
             <a:endParaRPr lang="en-US" dirty="0"/>
           </a:p>
         </p:txBody>
@@ -591,10 +368,6 @@
           <a:bodyPr/>
           <a:lstStyle/>
           <a:p>
-            <a:r>
-              <a:rPr lang="en-US" dirty="0"/>
-              <a:t/>
-            </a:r>
             <a:endParaRPr lang="en-US" dirty="0"/>
           </a:p>
         </p:txBody>
@@ -679,10 +452,6 @@
           <a:bodyPr/>
           <a:lstStyle/>
           <a:p>
-            <a:r>
-              <a:rPr lang="en-US" dirty="0"/>
-              <a:t/>
-            </a:r>
             <a:endParaRPr lang="en-US" dirty="0"/>
           </a:p>
         </p:txBody>
@@ -767,10 +536,6 @@
           <a:bodyPr/>
           <a:lstStyle/>
           <a:p>
-            <a:r>
-              <a:rPr lang="en-US" dirty="0"/>
-              <a:t/>
-            </a:r>
             <a:endParaRPr lang="en-US" dirty="0"/>
           </a:p>
         </p:txBody>
@@ -844,6 +609,11 @@
 <file path=ppt/slideMasters/slideMaster1.xml><?xml version="1.0" encoding="utf-8"?>
 <p:sldMaster xmlns:a="http://schemas.openxmlformats.org/drawingml/2006/main" xmlns:r="http://schemas.openxmlformats.org/officeDocument/2006/relationships" xmlns:p="http://schemas.openxmlformats.org/presentationml/2006/main">
   <p:cSld>
+    <p:bg>
+      <p:bgRef idx="1001">
+        <a:schemeClr val="bg1"/>
+      </p:bgRef>
+    </p:bg>
     <p:spTree>
       <p:nvGrpSpPr>
         <p:cNvPr id="1" name=""/>
@@ -1137,14 +907,14 @@
       </p:grpSpPr>
       <p:pic>
         <p:nvPicPr>
-          <p:cNvPr id="2" name="Image 0" descr="preencoded.png">    </p:cNvPr>
+          <p:cNvPr id="2" name="Image 0" descr="preencoded.png"/>
           <p:cNvPicPr>
             <a:picLocks noChangeAspect="1"/>
           </p:cNvPicPr>
           <p:nvPr/>
         </p:nvPicPr>
         <p:blipFill>
-          <a:blip r:embed="rId1"/>
+          <a:blip r:embed="rId3"/>
           <a:stretch>
             <a:fillRect/>
           </a:stretch>
@@ -1161,14 +931,14 @@
       </p:pic>
       <p:pic>
         <p:nvPicPr>
-          <p:cNvPr id="3" name="Image 1" descr="preencoded.png">    </p:cNvPr>
+          <p:cNvPr id="3" name="Image 1" descr="preencoded.png"/>
           <p:cNvPicPr>
             <a:picLocks noChangeAspect="1"/>
           </p:cNvPicPr>
           <p:nvPr/>
         </p:nvPicPr>
         <p:blipFill>
-          <a:blip r:embed="rId2"/>
+          <a:blip r:embed="rId4"/>
           <a:stretch>
             <a:fillRect/>
           </a:stretch>
@@ -1191,8 +961,8 @@
         </p:nvSpPr>
         <p:spPr>
           <a:xfrm>
-            <a:off x="3437037" y="1895270"/>
-            <a:ext cx="2269927" cy="967978"/>
+            <a:off x="2750207" y="1895270"/>
+            <a:ext cx="3433379" cy="967978"/>
           </a:xfrm>
           <a:prstGeom prst="rect">
             <a:avLst/>
@@ -1206,11 +976,11 @@
           </a:bodyPr>
           <a:lstStyle/>
           <a:p>
-            <a:pPr algn="ctr" indent="0" marL="0">
-              <a:buNone/>
-            </a:pPr>
-            <a:r>
-              <a:rPr lang="en-US" sz="6050" spc="-2" kern="0" dirty="0">
+            <a:pPr marL="0" indent="0" algn="ctr">
+              <a:buNone/>
+            </a:pPr>
+            <a:r>
+              <a:rPr lang="en-US" sz="6050" kern="0" spc="-2" dirty="0">
                 <a:solidFill>
                   <a:srgbClr val="1D9E75"/>
                 </a:solidFill>
@@ -1218,18 +988,7 @@
                 <a:ea typeface="Fraunces" pitchFamily="34" charset="-122"/>
                 <a:cs typeface="Fraunces" pitchFamily="34" charset="-120"/>
               </a:rPr>
-              <a:t>Magpie</a:t>
-            </a:r>
-            <a:r>
-              <a:rPr lang="en-US" sz="6050" spc="-2" kern="0" dirty="0">
-                <a:solidFill>
-                  <a:srgbClr val="1D9E75"/>
-                </a:solidFill>
-                <a:latin typeface="Fraunces" pitchFamily="34" charset="0"/>
-                <a:ea typeface="Fraunces" pitchFamily="34" charset="-122"/>
-                <a:cs typeface="Fraunces" pitchFamily="34" charset="-120"/>
-              </a:rPr>
-              <a:t>.</a:t>
+              <a:t>Magpie.</a:t>
             </a:r>
             <a:endParaRPr lang="en-US" sz="6050" dirty="0"/>
           </a:p>
@@ -1258,7 +1017,7 @@
           </a:bodyPr>
           <a:lstStyle/>
           <a:p>
-            <a:pPr algn="ctr" indent="0" marL="0">
+            <a:pPr marL="0" indent="0" algn="ctr">
               <a:buNone/>
             </a:pPr>
             <a:r>
@@ -1299,7 +1058,7 @@
           </a:bodyPr>
           <a:lstStyle/>
           <a:p>
-            <a:pPr algn="ctr" indent="0" marL="0">
+            <a:pPr marL="0" indent="0" algn="ctr">
               <a:lnSpc>
                 <a:spcPct val="128000"/>
               </a:lnSpc>
@@ -1343,11 +1102,11 @@
           </a:bodyPr>
           <a:lstStyle/>
           <a:p>
-            <a:pPr algn="l" indent="0" marL="0">
-              <a:buNone/>
-            </a:pPr>
-            <a:r>
-              <a:rPr lang="en-US" sz="850" spc="1" kern="0" dirty="0">
+            <a:pPr marL="0" indent="0" algn="l">
+              <a:buNone/>
+            </a:pPr>
+            <a:r>
+              <a:rPr lang="en-US" sz="850" kern="0" spc="1" dirty="0">
                 <a:solidFill>
                   <a:srgbClr val="A5A39A"/>
                 </a:solidFill>
@@ -1388,247 +1147,7 @@
       </p:grpSpPr>
       <p:pic>
         <p:nvPicPr>
-          <p:cNvPr id="2" name="Image 0" descr="preencoded.png">    </p:cNvPr>
-          <p:cNvPicPr>
-            <a:picLocks noChangeAspect="1"/>
-          </p:cNvPicPr>
-          <p:nvPr/>
-        </p:nvPicPr>
-        <p:blipFill>
-          <a:blip r:embed="rId1"/>
-          <a:stretch>
-            <a:fillRect/>
-          </a:stretch>
-        </p:blipFill>
-        <p:spPr>
-          <a:xfrm>
-            <a:off x="0" y="0"/>
-            <a:ext cx="9144000" cy="5784652"/>
-          </a:xfrm>
-          <a:prstGeom prst="rect">
-            <a:avLst/>
-          </a:prstGeom>
-        </p:spPr>
-      </p:pic>
-      <p:sp>
-        <p:nvSpPr>
-          <p:cNvPr id="3" name="Text 0"/>
-          <p:cNvSpPr/>
-          <p:nvPr/>
-        </p:nvSpPr>
-        <p:spPr>
-          <a:xfrm>
-            <a:off x="714375" y="571500"/>
-            <a:ext cx="7715250" cy="985838"/>
-          </a:xfrm>
-          <a:prstGeom prst="rect">
-            <a:avLst/>
-          </a:prstGeom>
-          <a:noFill/>
-          <a:ln/>
-        </p:spPr>
-        <p:txBody>
-          <a:bodyPr wrap="square" lIns="0" tIns="0" rIns="0" bIns="0" rtlCol="0" anchor="t">
-            <a:spAutoFit/>
-          </a:bodyPr>
-          <a:lstStyle/>
-          <a:p>
-            <a:pPr algn="l" indent="0" marL="0">
-              <a:buNone/>
-            </a:pPr>
-            <a:r>
-              <a:rPr lang="en-US" sz="3050" spc="-1" kern="0" dirty="0">
-                <a:solidFill>
-                  <a:srgbClr val="F5F4EF"/>
-                </a:solidFill>
-                <a:latin typeface="Fraunces" pitchFamily="34" charset="0"/>
-                <a:ea typeface="Fraunces" pitchFamily="34" charset="-122"/>
-                <a:cs typeface="Fraunces" pitchFamily="34" charset="-120"/>
-              </a:rPr>
-              <a:t>Three dimensions. Five modes. One conversation.</a:t>
-            </a:r>
-            <a:endParaRPr lang="en-US" sz="3050" dirty="0"/>
-          </a:p>
-        </p:txBody>
-      </p:sp>
-      <p:sp>
-        <p:nvSpPr>
-          <p:cNvPr id="4" name="Text 1"/>
-          <p:cNvSpPr/>
-          <p:nvPr/>
-        </p:nvSpPr>
-        <p:spPr>
-          <a:xfrm>
-            <a:off x="714375" y="1700213"/>
-            <a:ext cx="6429375" cy="514350"/>
-          </a:xfrm>
-          <a:prstGeom prst="rect">
-            <a:avLst/>
-          </a:prstGeom>
-          <a:noFill/>
-          <a:ln/>
-        </p:spPr>
-        <p:txBody>
-          <a:bodyPr wrap="square" lIns="0" tIns="0" rIns="0" bIns="0" rtlCol="0" anchor="t">
-            <a:spAutoFit/>
-          </a:bodyPr>
-          <a:lstStyle/>
-          <a:p>
-            <a:pPr algn="l" indent="0" marL="0">
-              <a:lnSpc>
-                <a:spcPct val="120000"/>
-              </a:lnSpc>
-              <a:buNone/>
-            </a:pPr>
-            <a:r>
-              <a:rPr lang="en-US" sz="1250" dirty="0">
-                <a:solidFill>
-                  <a:srgbClr val="A5A39A"/>
-                </a:solidFill>
-                <a:latin typeface="DM Sans" pitchFamily="34" charset="0"/>
-                <a:ea typeface="DM Sans" pitchFamily="34" charset="-122"/>
-                <a:cs typeface="DM Sans" pitchFamily="34" charset="-120"/>
-              </a:rPr>
-              <a:t>Every thought finds its place in a wiki that grows with you. </a:t>
-            </a:r>
-            <a:r>
-              <a:rPr lang="en-US" sz="1250" dirty="0">
-                <a:solidFill>
-                  <a:srgbClr val="F5F4EF"/>
-                </a:solidFill>
-                <a:latin typeface="DM Sans Medium" pitchFamily="34" charset="0"/>
-                <a:ea typeface="DM Sans Medium" pitchFamily="34" charset="-122"/>
-                <a:cs typeface="DM Sans Medium" pitchFamily="34" charset="-120"/>
-              </a:rPr>
-              <a:t>Subject. Topic. Facet.</a:t>
-            </a:r>
-            <a:r>
-              <a:rPr lang="en-US" sz="1250" dirty="0">
-                <a:solidFill>
-                  <a:srgbClr val="A5A39A"/>
-                </a:solidFill>
-                <a:latin typeface="DM Sans" pitchFamily="34" charset="0"/>
-                <a:ea typeface="DM Sans" pitchFamily="34" charset="-122"/>
-                <a:cs typeface="DM Sans" pitchFamily="34" charset="-120"/>
-              </a:rPr>
-              <a:t> Add bullets when something hits, then explore from any angle.</a:t>
-            </a:r>
-            <a:endParaRPr lang="en-US" sz="1250" dirty="0"/>
-          </a:p>
-        </p:txBody>
-      </p:sp>
-      <p:pic>
-        <p:nvPicPr>
-          <p:cNvPr id="5" name="Image 1" descr="preencoded.png">    </p:cNvPr>
-          <p:cNvPicPr>
-            <a:picLocks noChangeAspect="1"/>
-          </p:cNvPicPr>
-          <p:nvPr/>
-        </p:nvPicPr>
-        <p:blipFill>
-          <a:blip r:embed="rId2"/>
-          <a:stretch>
-            <a:fillRect/>
-          </a:stretch>
-        </p:blipFill>
-        <p:spPr>
-          <a:xfrm>
-            <a:off x="714375" y="2857500"/>
-            <a:ext cx="171450" cy="228600"/>
-          </a:xfrm>
-          <a:prstGeom prst="rect">
-            <a:avLst/>
-          </a:prstGeom>
-        </p:spPr>
-      </p:pic>
-      <p:sp>
-        <p:nvSpPr>
-          <p:cNvPr id="6" name="Text 2"/>
-          <p:cNvSpPr/>
-          <p:nvPr/>
-        </p:nvSpPr>
-        <p:spPr>
-          <a:xfrm>
-            <a:off x="714375" y="3228975"/>
-            <a:ext cx="667941" cy="248245"/>
-          </a:xfrm>
-          <a:prstGeom prst="rect">
-            <a:avLst/>
-          </a:prstGeom>
-          <a:noFill/>
-          <a:ln/>
-        </p:spPr>
-        <p:txBody>
-          <a:bodyPr wrap="none" lIns="0" tIns="0" rIns="0" bIns="0" rtlCol="0" anchor="t">
-            <a:spAutoFit/>
-          </a:bodyPr>
-          <a:lstStyle/>
-          <a:p>
-            <a:pPr algn="l" indent="0" marL="0">
-              <a:buNone/>
-            </a:pPr>
-            <a:r>
-              <a:rPr lang="en-US" sz="1500" dirty="0">
-                <a:solidFill>
-                  <a:srgbClr val="F5F4EF"/>
-                </a:solidFill>
-                <a:latin typeface="Fraunces" pitchFamily="34" charset="0"/>
-                <a:ea typeface="Fraunces" pitchFamily="34" charset="-122"/>
-                <a:cs typeface="Fraunces" pitchFamily="34" charset="-120"/>
-              </a:rPr>
-              <a:t>Maggie</a:t>
-            </a:r>
-            <a:endParaRPr lang="en-US" sz="1500" dirty="0"/>
-          </a:p>
-        </p:txBody>
-      </p:sp>
-      <p:sp>
-        <p:nvSpPr>
-          <p:cNvPr id="7" name="Text 3"/>
-          <p:cNvSpPr/>
-          <p:nvPr/>
-        </p:nvSpPr>
-        <p:spPr>
-          <a:xfrm>
-            <a:off x="714375" y="3584377"/>
-            <a:ext cx="1371600" cy="578644"/>
-          </a:xfrm>
-          <a:prstGeom prst="rect">
-            <a:avLst/>
-          </a:prstGeom>
-          <a:noFill/>
-          <a:ln/>
-        </p:spPr>
-        <p:txBody>
-          <a:bodyPr wrap="square" lIns="0" tIns="0" rIns="0" bIns="0" rtlCol="0" anchor="t">
-            <a:spAutoFit/>
-          </a:bodyPr>
-          <a:lstStyle/>
-          <a:p>
-            <a:pPr algn="l" indent="0" marL="0">
-              <a:lnSpc>
-                <a:spcPct val="120000"/>
-              </a:lnSpc>
-              <a:buNone/>
-            </a:pPr>
-            <a:r>
-              <a:rPr lang="en-US" sz="950" dirty="0">
-                <a:solidFill>
-                  <a:srgbClr val="A5A39A"/>
-                </a:solidFill>
-                <a:latin typeface="DM Sans" pitchFamily="34" charset="0"/>
-                <a:ea typeface="DM Sans" pitchFamily="34" charset="-122"/>
-                <a:cs typeface="DM Sans" pitchFamily="34" charset="-120"/>
-              </a:rPr>
-              <a:t>Voice-first capture. Tap the mic, talk, bullets appear.</a:t>
-            </a:r>
-            <a:endParaRPr lang="en-US" sz="950" dirty="0"/>
-          </a:p>
-        </p:txBody>
-      </p:sp>
-      <p:pic>
-        <p:nvPicPr>
-          <p:cNvPr id="8" name="Image 2" descr="preencoded.png">    </p:cNvPr>
+          <p:cNvPr id="2" name="Image 0" descr="preencoded.png"/>
           <p:cNvPicPr>
             <a:picLocks noChangeAspect="1"/>
           </p:cNvPicPr>
@@ -1642,8 +1161,8 @@
         </p:blipFill>
         <p:spPr>
           <a:xfrm>
-            <a:off x="2300288" y="2857500"/>
-            <a:ext cx="171450" cy="228600"/>
+            <a:off x="0" y="0"/>
+            <a:ext cx="9144000" cy="5784652"/>
           </a:xfrm>
           <a:prstGeom prst="rect">
             <a:avLst/>
@@ -1652,32 +1171,32 @@
       </p:pic>
       <p:sp>
         <p:nvSpPr>
-          <p:cNvPr id="9" name="Text 4"/>
-          <p:cNvSpPr/>
-          <p:nvPr/>
-        </p:nvSpPr>
-        <p:spPr>
-          <a:xfrm>
-            <a:off x="2300288" y="3228975"/>
-            <a:ext cx="455414" cy="248245"/>
-          </a:xfrm>
-          <a:prstGeom prst="rect">
-            <a:avLst/>
-          </a:prstGeom>
-          <a:noFill/>
-          <a:ln/>
-        </p:spPr>
-        <p:txBody>
-          <a:bodyPr wrap="none" lIns="0" tIns="0" rIns="0" bIns="0" rtlCol="0" anchor="t">
-            <a:spAutoFit/>
-          </a:bodyPr>
-          <a:lstStyle/>
-          <a:p>
-            <a:pPr algn="l" indent="0" marL="0">
-              <a:buNone/>
-            </a:pPr>
-            <a:r>
-              <a:rPr lang="en-US" sz="1500" dirty="0">
+          <p:cNvPr id="3" name="Text 0"/>
+          <p:cNvSpPr/>
+          <p:nvPr/>
+        </p:nvSpPr>
+        <p:spPr>
+          <a:xfrm>
+            <a:off x="714375" y="571500"/>
+            <a:ext cx="7715250" cy="985838"/>
+          </a:xfrm>
+          <a:prstGeom prst="rect">
+            <a:avLst/>
+          </a:prstGeom>
+          <a:noFill/>
+          <a:ln/>
+        </p:spPr>
+        <p:txBody>
+          <a:bodyPr wrap="square" lIns="0" tIns="0" rIns="0" bIns="0" rtlCol="0" anchor="t">
+            <a:spAutoFit/>
+          </a:bodyPr>
+          <a:lstStyle/>
+          <a:p>
+            <a:pPr marL="0" indent="0" algn="l">
+              <a:buNone/>
+            </a:pPr>
+            <a:r>
+              <a:rPr lang="en-US" sz="3050" kern="0" spc="-1" dirty="0">
                 <a:solidFill>
                   <a:srgbClr val="F5F4EF"/>
                 </a:solidFill>
@@ -1685,22 +1204,22 @@
                 <a:ea typeface="Fraunces" pitchFamily="34" charset="-122"/>
                 <a:cs typeface="Fraunces" pitchFamily="34" charset="-120"/>
               </a:rPr>
-              <a:t>Brief</a:t>
-            </a:r>
-            <a:endParaRPr lang="en-US" sz="1500" dirty="0"/>
-          </a:p>
-        </p:txBody>
-      </p:sp>
-      <p:sp>
-        <p:nvSpPr>
-          <p:cNvPr id="10" name="Text 5"/>
-          <p:cNvSpPr/>
-          <p:nvPr/>
-        </p:nvSpPr>
-        <p:spPr>
-          <a:xfrm>
-            <a:off x="2300288" y="3584377"/>
-            <a:ext cx="1371600" cy="578644"/>
+              <a:t>Three dimensions. Five modes. One conversation.</a:t>
+            </a:r>
+            <a:endParaRPr lang="en-US" sz="3050" dirty="0"/>
+          </a:p>
+        </p:txBody>
+      </p:sp>
+      <p:sp>
+        <p:nvSpPr>
+          <p:cNvPr id="4" name="Text 1"/>
+          <p:cNvSpPr/>
+          <p:nvPr/>
+        </p:nvSpPr>
+        <p:spPr>
+          <a:xfrm>
+            <a:off x="714375" y="1700213"/>
+            <a:ext cx="6429375" cy="514350"/>
           </a:xfrm>
           <a:prstGeom prst="rect">
             <a:avLst/>
@@ -1714,14 +1233,14 @@
           </a:bodyPr>
           <a:lstStyle/>
           <a:p>
-            <a:pPr algn="l" indent="0" marL="0">
+            <a:pPr marL="0" indent="0" algn="l">
               <a:lnSpc>
                 <a:spcPct val="120000"/>
               </a:lnSpc>
               <a:buNone/>
             </a:pPr>
             <a:r>
-              <a:rPr lang="en-US" sz="950" dirty="0">
+              <a:rPr lang="en-US" sz="1250" dirty="0">
                 <a:solidFill>
                   <a:srgbClr val="A5A39A"/>
                 </a:solidFill>
@@ -1729,15 +1248,37 @@
                 <a:ea typeface="DM Sans" pitchFamily="34" charset="-122"/>
                 <a:cs typeface="DM Sans" pitchFamily="34" charset="-120"/>
               </a:rPr>
-              <a:t>A smart primer on any topic before a dinner party.</a:t>
-            </a:r>
-            <a:endParaRPr lang="en-US" sz="950" dirty="0"/>
+              <a:t>Every thought finds its place in a wiki that grows with you. </a:t>
+            </a:r>
+            <a:r>
+              <a:rPr lang="en-US" sz="1250" dirty="0">
+                <a:solidFill>
+                  <a:srgbClr val="F5F4EF"/>
+                </a:solidFill>
+                <a:latin typeface="DM Sans Medium" pitchFamily="34" charset="0"/>
+                <a:ea typeface="DM Sans Medium" pitchFamily="34" charset="-122"/>
+                <a:cs typeface="DM Sans Medium" pitchFamily="34" charset="-120"/>
+              </a:rPr>
+              <a:t>Subject. Topic. Facet.</a:t>
+            </a:r>
+            <a:r>
+              <a:rPr lang="en-US" sz="1250" dirty="0">
+                <a:solidFill>
+                  <a:srgbClr val="A5A39A"/>
+                </a:solidFill>
+                <a:latin typeface="DM Sans" pitchFamily="34" charset="0"/>
+                <a:ea typeface="DM Sans" pitchFamily="34" charset="-122"/>
+                <a:cs typeface="DM Sans" pitchFamily="34" charset="-120"/>
+              </a:rPr>
+              <a:t> Add bullets when something hits, then explore from any angle.</a:t>
+            </a:r>
+            <a:endParaRPr lang="en-US" sz="1250" dirty="0"/>
           </a:p>
         </p:txBody>
       </p:sp>
       <p:pic>
         <p:nvPicPr>
-          <p:cNvPr id="11" name="Image 3" descr="preencoded.png">    </p:cNvPr>
+          <p:cNvPr id="5" name="Image 1" descr="preencoded.png"/>
           <p:cNvPicPr>
             <a:picLocks noChangeAspect="1"/>
           </p:cNvPicPr>
@@ -1751,7 +1292,7 @@
         </p:blipFill>
         <p:spPr>
           <a:xfrm>
-            <a:off x="3886200" y="2857500"/>
+            <a:off x="714375" y="2857500"/>
             <a:ext cx="171450" cy="228600"/>
           </a:xfrm>
           <a:prstGeom prst="rect">
@@ -1761,14 +1302,14 @@
       </p:pic>
       <p:sp>
         <p:nvSpPr>
-          <p:cNvPr id="12" name="Text 6"/>
-          <p:cNvSpPr/>
-          <p:nvPr/>
-        </p:nvSpPr>
-        <p:spPr>
-          <a:xfrm>
-            <a:off x="3886200" y="3228975"/>
-            <a:ext cx="923330" cy="248245"/>
+          <p:cNvPr id="6" name="Text 2"/>
+          <p:cNvSpPr/>
+          <p:nvPr/>
+        </p:nvSpPr>
+        <p:spPr>
+          <a:xfrm>
+            <a:off x="714375" y="3228975"/>
+            <a:ext cx="667941" cy="248245"/>
           </a:xfrm>
           <a:prstGeom prst="rect">
             <a:avLst/>
@@ -1782,7 +1323,7 @@
           </a:bodyPr>
           <a:lstStyle/>
           <a:p>
-            <a:pPr algn="l" indent="0" marL="0">
+            <a:pPr marL="0" indent="0" algn="l">
               <a:buNone/>
             </a:pPr>
             <a:r>
@@ -1794,7 +1335,7 @@
                 <a:ea typeface="Fraunces" pitchFamily="34" charset="-122"/>
                 <a:cs typeface="Fraunces" pitchFamily="34" charset="-120"/>
               </a:rPr>
-              <a:t>Challenge</a:t>
+              <a:t>Maggie</a:t>
             </a:r>
             <a:endParaRPr lang="en-US" sz="1500" dirty="0"/>
           </a:p>
@@ -1802,13 +1343,13 @@
       </p:sp>
       <p:sp>
         <p:nvSpPr>
-          <p:cNvPr id="13" name="Text 7"/>
-          <p:cNvSpPr/>
-          <p:nvPr/>
-        </p:nvSpPr>
-        <p:spPr>
-          <a:xfrm>
-            <a:off x="3886200" y="3584377"/>
+          <p:cNvPr id="7" name="Text 3"/>
+          <p:cNvSpPr/>
+          <p:nvPr/>
+        </p:nvSpPr>
+        <p:spPr>
+          <a:xfrm>
+            <a:off x="714375" y="3584377"/>
             <a:ext cx="1371600" cy="578644"/>
           </a:xfrm>
           <a:prstGeom prst="rect">
@@ -1823,7 +1364,7 @@
           </a:bodyPr>
           <a:lstStyle/>
           <a:p>
-            <a:pPr algn="l" indent="0" marL="0">
+            <a:pPr marL="0" indent="0" algn="l">
               <a:lnSpc>
                 <a:spcPct val="120000"/>
               </a:lnSpc>
@@ -1838,7 +1379,7 @@
                 <a:ea typeface="DM Sans" pitchFamily="34" charset="-122"/>
                 <a:cs typeface="DM Sans" pitchFamily="34" charset="-120"/>
               </a:rPr>
-              <a:t>A steelman or paradox that sharpens your thinking.</a:t>
+              <a:t>Voice-first capture. Tap the mic, talk, bullets appear.</a:t>
             </a:r>
             <a:endParaRPr lang="en-US" sz="950" dirty="0"/>
           </a:p>
@@ -1846,7 +1387,7 @@
       </p:sp>
       <p:pic>
         <p:nvPicPr>
-          <p:cNvPr id="14" name="Image 4" descr="preencoded.png">    </p:cNvPr>
+          <p:cNvPr id="8" name="Image 2" descr="preencoded.png"/>
           <p:cNvPicPr>
             <a:picLocks noChangeAspect="1"/>
           </p:cNvPicPr>
@@ -1860,8 +1401,8 @@
         </p:blipFill>
         <p:spPr>
           <a:xfrm>
-            <a:off x="5472113" y="2857500"/>
-            <a:ext cx="228600" cy="228600"/>
+            <a:off x="2300288" y="2857500"/>
+            <a:ext cx="171450" cy="228600"/>
           </a:xfrm>
           <a:prstGeom prst="rect">
             <a:avLst/>
@@ -1870,14 +1411,14 @@
       </p:pic>
       <p:sp>
         <p:nvSpPr>
-          <p:cNvPr id="15" name="Text 8"/>
-          <p:cNvSpPr/>
-          <p:nvPr/>
-        </p:nvSpPr>
-        <p:spPr>
-          <a:xfrm>
-            <a:off x="5472113" y="3228975"/>
-            <a:ext cx="926902" cy="248245"/>
+          <p:cNvPr id="9" name="Text 4"/>
+          <p:cNvSpPr/>
+          <p:nvPr/>
+        </p:nvSpPr>
+        <p:spPr>
+          <a:xfrm>
+            <a:off x="2300288" y="3228975"/>
+            <a:ext cx="455414" cy="248245"/>
           </a:xfrm>
           <a:prstGeom prst="rect">
             <a:avLst/>
@@ -1891,7 +1432,7 @@
           </a:bodyPr>
           <a:lstStyle/>
           <a:p>
-            <a:pPr algn="l" indent="0" marL="0">
+            <a:pPr marL="0" indent="0" algn="l">
               <a:buNone/>
             </a:pPr>
             <a:r>
@@ -1903,7 +1444,7 @@
                 <a:ea typeface="Fraunces" pitchFamily="34" charset="-122"/>
                 <a:cs typeface="Fraunces" pitchFamily="34" charset="-120"/>
               </a:rPr>
-              <a:t>Questions</a:t>
+              <a:t>Brief</a:t>
             </a:r>
             <a:endParaRPr lang="en-US" sz="1500" dirty="0"/>
           </a:p>
@@ -1911,13 +1452,13 @@
       </p:sp>
       <p:sp>
         <p:nvSpPr>
-          <p:cNvPr id="16" name="Text 9"/>
-          <p:cNvSpPr/>
-          <p:nvPr/>
-        </p:nvSpPr>
-        <p:spPr>
-          <a:xfrm>
-            <a:off x="5472113" y="3584377"/>
+          <p:cNvPr id="10" name="Text 5"/>
+          <p:cNvSpPr/>
+          <p:nvPr/>
+        </p:nvSpPr>
+        <p:spPr>
+          <a:xfrm>
+            <a:off x="2300288" y="3584377"/>
             <a:ext cx="1371600" cy="578644"/>
           </a:xfrm>
           <a:prstGeom prst="rect">
@@ -1932,7 +1473,7 @@
           </a:bodyPr>
           <a:lstStyle/>
           <a:p>
-            <a:pPr algn="l" indent="0" marL="0">
+            <a:pPr marL="0" indent="0" algn="l">
               <a:lnSpc>
                 <a:spcPct val="120000"/>
               </a:lnSpc>
@@ -1947,7 +1488,7 @@
                 <a:ea typeface="DM Sans" pitchFamily="34" charset="-122"/>
                 <a:cs typeface="DM Sans" pitchFamily="34" charset="-120"/>
               </a:rPr>
-              <a:t>Open questions that make people feel interesting.</a:t>
+              <a:t>A smart primer on any topic before a dinner party.</a:t>
             </a:r>
             <a:endParaRPr lang="en-US" sz="950" dirty="0"/>
           </a:p>
@@ -1955,7 +1496,7 @@
       </p:sp>
       <p:pic>
         <p:nvPicPr>
-          <p:cNvPr id="17" name="Image 5" descr="preencoded.png">    </p:cNvPr>
+          <p:cNvPr id="11" name="Image 3" descr="preencoded.png"/>
           <p:cNvPicPr>
             <a:picLocks noChangeAspect="1"/>
           </p:cNvPicPr>
@@ -1969,8 +1510,8 @@
         </p:blipFill>
         <p:spPr>
           <a:xfrm>
-            <a:off x="7058025" y="2857500"/>
-            <a:ext cx="228600" cy="228600"/>
+            <a:off x="3886200" y="2857500"/>
+            <a:ext cx="171450" cy="228600"/>
           </a:xfrm>
           <a:prstGeom prst="rect">
             <a:avLst/>
@@ -1979,14 +1520,14 @@
       </p:pic>
       <p:sp>
         <p:nvSpPr>
-          <p:cNvPr id="18" name="Text 10"/>
-          <p:cNvSpPr/>
-          <p:nvPr/>
-        </p:nvSpPr>
-        <p:spPr>
-          <a:xfrm>
-            <a:off x="7058025" y="3228975"/>
-            <a:ext cx="592931" cy="248245"/>
+          <p:cNvPr id="12" name="Text 6"/>
+          <p:cNvSpPr/>
+          <p:nvPr/>
+        </p:nvSpPr>
+        <p:spPr>
+          <a:xfrm>
+            <a:off x="3886200" y="3228975"/>
+            <a:ext cx="923330" cy="248245"/>
           </a:xfrm>
           <a:prstGeom prst="rect">
             <a:avLst/>
@@ -2000,7 +1541,7 @@
           </a:bodyPr>
           <a:lstStyle/>
           <a:p>
-            <a:pPr algn="l" indent="0" marL="0">
+            <a:pPr marL="0" indent="0" algn="l">
               <a:buNone/>
             </a:pPr>
             <a:r>
@@ -2012,6 +1553,224 @@
                 <a:ea typeface="Fraunces" pitchFamily="34" charset="-122"/>
                 <a:cs typeface="Fraunces" pitchFamily="34" charset="-120"/>
               </a:rPr>
+              <a:t>Challenge</a:t>
+            </a:r>
+            <a:endParaRPr lang="en-US" sz="1500" dirty="0"/>
+          </a:p>
+        </p:txBody>
+      </p:sp>
+      <p:sp>
+        <p:nvSpPr>
+          <p:cNvPr id="13" name="Text 7"/>
+          <p:cNvSpPr/>
+          <p:nvPr/>
+        </p:nvSpPr>
+        <p:spPr>
+          <a:xfrm>
+            <a:off x="3886200" y="3584377"/>
+            <a:ext cx="1371600" cy="578644"/>
+          </a:xfrm>
+          <a:prstGeom prst="rect">
+            <a:avLst/>
+          </a:prstGeom>
+          <a:noFill/>
+          <a:ln/>
+        </p:spPr>
+        <p:txBody>
+          <a:bodyPr wrap="square" lIns="0" tIns="0" rIns="0" bIns="0" rtlCol="0" anchor="t">
+            <a:spAutoFit/>
+          </a:bodyPr>
+          <a:lstStyle/>
+          <a:p>
+            <a:pPr marL="0" indent="0" algn="l">
+              <a:lnSpc>
+                <a:spcPct val="120000"/>
+              </a:lnSpc>
+              <a:buNone/>
+            </a:pPr>
+            <a:r>
+              <a:rPr lang="en-US" sz="950" dirty="0">
+                <a:solidFill>
+                  <a:srgbClr val="A5A39A"/>
+                </a:solidFill>
+                <a:latin typeface="DM Sans" pitchFamily="34" charset="0"/>
+                <a:ea typeface="DM Sans" pitchFamily="34" charset="-122"/>
+                <a:cs typeface="DM Sans" pitchFamily="34" charset="-120"/>
+              </a:rPr>
+              <a:t>A steelman or paradox that sharpens your thinking.</a:t>
+            </a:r>
+            <a:endParaRPr lang="en-US" sz="950" dirty="0"/>
+          </a:p>
+        </p:txBody>
+      </p:sp>
+      <p:pic>
+        <p:nvPicPr>
+          <p:cNvPr id="14" name="Image 4" descr="preencoded.png"/>
+          <p:cNvPicPr>
+            <a:picLocks noChangeAspect="1"/>
+          </p:cNvPicPr>
+          <p:nvPr/>
+        </p:nvPicPr>
+        <p:blipFill>
+          <a:blip r:embed="rId7"/>
+          <a:stretch>
+            <a:fillRect/>
+          </a:stretch>
+        </p:blipFill>
+        <p:spPr>
+          <a:xfrm>
+            <a:off x="5472113" y="2857500"/>
+            <a:ext cx="228600" cy="228600"/>
+          </a:xfrm>
+          <a:prstGeom prst="rect">
+            <a:avLst/>
+          </a:prstGeom>
+        </p:spPr>
+      </p:pic>
+      <p:sp>
+        <p:nvSpPr>
+          <p:cNvPr id="15" name="Text 8"/>
+          <p:cNvSpPr/>
+          <p:nvPr/>
+        </p:nvSpPr>
+        <p:spPr>
+          <a:xfrm>
+            <a:off x="5472113" y="3228975"/>
+            <a:ext cx="926902" cy="248245"/>
+          </a:xfrm>
+          <a:prstGeom prst="rect">
+            <a:avLst/>
+          </a:prstGeom>
+          <a:noFill/>
+          <a:ln/>
+        </p:spPr>
+        <p:txBody>
+          <a:bodyPr wrap="none" lIns="0" tIns="0" rIns="0" bIns="0" rtlCol="0" anchor="t">
+            <a:spAutoFit/>
+          </a:bodyPr>
+          <a:lstStyle/>
+          <a:p>
+            <a:pPr marL="0" indent="0" algn="l">
+              <a:buNone/>
+            </a:pPr>
+            <a:r>
+              <a:rPr lang="en-US" sz="1500" dirty="0">
+                <a:solidFill>
+                  <a:srgbClr val="F5F4EF"/>
+                </a:solidFill>
+                <a:latin typeface="Fraunces" pitchFamily="34" charset="0"/>
+                <a:ea typeface="Fraunces" pitchFamily="34" charset="-122"/>
+                <a:cs typeface="Fraunces" pitchFamily="34" charset="-120"/>
+              </a:rPr>
+              <a:t>Questions</a:t>
+            </a:r>
+            <a:endParaRPr lang="en-US" sz="1500" dirty="0"/>
+          </a:p>
+        </p:txBody>
+      </p:sp>
+      <p:sp>
+        <p:nvSpPr>
+          <p:cNvPr id="16" name="Text 9"/>
+          <p:cNvSpPr/>
+          <p:nvPr/>
+        </p:nvSpPr>
+        <p:spPr>
+          <a:xfrm>
+            <a:off x="5472113" y="3584377"/>
+            <a:ext cx="1371600" cy="578644"/>
+          </a:xfrm>
+          <a:prstGeom prst="rect">
+            <a:avLst/>
+          </a:prstGeom>
+          <a:noFill/>
+          <a:ln/>
+        </p:spPr>
+        <p:txBody>
+          <a:bodyPr wrap="square" lIns="0" tIns="0" rIns="0" bIns="0" rtlCol="0" anchor="t">
+            <a:spAutoFit/>
+          </a:bodyPr>
+          <a:lstStyle/>
+          <a:p>
+            <a:pPr marL="0" indent="0" algn="l">
+              <a:lnSpc>
+                <a:spcPct val="120000"/>
+              </a:lnSpc>
+              <a:buNone/>
+            </a:pPr>
+            <a:r>
+              <a:rPr lang="en-US" sz="950" dirty="0">
+                <a:solidFill>
+                  <a:srgbClr val="A5A39A"/>
+                </a:solidFill>
+                <a:latin typeface="DM Sans" pitchFamily="34" charset="0"/>
+                <a:ea typeface="DM Sans" pitchFamily="34" charset="-122"/>
+                <a:cs typeface="DM Sans" pitchFamily="34" charset="-120"/>
+              </a:rPr>
+              <a:t>Open questions that make people feel interesting.</a:t>
+            </a:r>
+            <a:endParaRPr lang="en-US" sz="950" dirty="0"/>
+          </a:p>
+        </p:txBody>
+      </p:sp>
+      <p:pic>
+        <p:nvPicPr>
+          <p:cNvPr id="17" name="Image 5" descr="preencoded.png"/>
+          <p:cNvPicPr>
+            <a:picLocks noChangeAspect="1"/>
+          </p:cNvPicPr>
+          <p:nvPr/>
+        </p:nvPicPr>
+        <p:blipFill>
+          <a:blip r:embed="rId8"/>
+          <a:stretch>
+            <a:fillRect/>
+          </a:stretch>
+        </p:blipFill>
+        <p:spPr>
+          <a:xfrm>
+            <a:off x="7058025" y="2857500"/>
+            <a:ext cx="228600" cy="228600"/>
+          </a:xfrm>
+          <a:prstGeom prst="rect">
+            <a:avLst/>
+          </a:prstGeom>
+        </p:spPr>
+      </p:pic>
+      <p:sp>
+        <p:nvSpPr>
+          <p:cNvPr id="18" name="Text 10"/>
+          <p:cNvSpPr/>
+          <p:nvPr/>
+        </p:nvSpPr>
+        <p:spPr>
+          <a:xfrm>
+            <a:off x="7058025" y="3228975"/>
+            <a:ext cx="592931" cy="248245"/>
+          </a:xfrm>
+          <a:prstGeom prst="rect">
+            <a:avLst/>
+          </a:prstGeom>
+          <a:noFill/>
+          <a:ln/>
+        </p:spPr>
+        <p:txBody>
+          <a:bodyPr wrap="none" lIns="0" tIns="0" rIns="0" bIns="0" rtlCol="0" anchor="t">
+            <a:spAutoFit/>
+          </a:bodyPr>
+          <a:lstStyle/>
+          <a:p>
+            <a:pPr marL="0" indent="0" algn="l">
+              <a:buNone/>
+            </a:pPr>
+            <a:r>
+              <a:rPr lang="en-US" sz="1500" dirty="0">
+                <a:solidFill>
+                  <a:srgbClr val="F5F4EF"/>
+                </a:solidFill>
+                <a:latin typeface="Fraunces" pitchFamily="34" charset="0"/>
+                <a:ea typeface="Fraunces" pitchFamily="34" charset="-122"/>
+                <a:cs typeface="Fraunces" pitchFamily="34" charset="-120"/>
+              </a:rPr>
               <a:t>Convo</a:t>
             </a:r>
             <a:endParaRPr lang="en-US" sz="1500" dirty="0"/>
@@ -2041,7 +1800,7 @@
           </a:bodyPr>
           <a:lstStyle/>
           <a:p>
-            <a:pPr algn="l" indent="0" marL="0">
+            <a:pPr marL="0" indent="0" algn="l">
               <a:lnSpc>
                 <a:spcPct val="120000"/>
               </a:lnSpc>
@@ -2083,6 +1842,13 @@
           </a:solidFill>
           <a:ln/>
         </p:spPr>
+        <p:txBody>
+          <a:bodyPr/>
+          <a:lstStyle/>
+          <a:p>
+            <a:endParaRPr lang="en-US"/>
+          </a:p>
+        </p:txBody>
       </p:sp>
       <p:sp>
         <p:nvSpPr>
@@ -2103,6 +1869,13 @@
           </a:solidFill>
           <a:ln/>
         </p:spPr>
+        <p:txBody>
+          <a:bodyPr/>
+          <a:lstStyle/>
+          <a:p>
+            <a:endParaRPr lang="en-US"/>
+          </a:p>
+        </p:txBody>
       </p:sp>
       <p:sp>
         <p:nvSpPr>
@@ -2127,7 +1900,7 @@
           </a:bodyPr>
           <a:lstStyle/>
           <a:p>
-            <a:pPr algn="l" indent="0" marL="0">
+            <a:pPr marL="0" indent="0" algn="l">
               <a:buNone/>
             </a:pPr>
             <a:r>
@@ -2168,7 +1941,7 @@
           </a:bodyPr>
           <a:lstStyle/>
           <a:p>
-            <a:pPr algn="l" indent="0" marL="0">
+            <a:pPr marL="0" indent="0" algn="l">
               <a:lnSpc>
                 <a:spcPct val="128000"/>
               </a:lnSpc>
@@ -2216,14 +1989,14 @@
       </p:grpSpPr>
       <p:pic>
         <p:nvPicPr>
-          <p:cNvPr id="2" name="Image 0" descr="preencoded.png">    </p:cNvPr>
+          <p:cNvPr id="2" name="Image 0" descr="preencoded.png"/>
           <p:cNvPicPr>
             <a:picLocks noChangeAspect="1"/>
           </p:cNvPicPr>
           <p:nvPr/>
         </p:nvPicPr>
         <p:blipFill>
-          <a:blip r:embed="rId1"/>
+          <a:blip r:embed="rId3"/>
           <a:stretch>
             <a:fillRect/>
           </a:stretch>
@@ -2259,6 +2032,13 @@
           </a:solidFill>
           <a:ln/>
         </p:spPr>
+        <p:txBody>
+          <a:bodyPr/>
+          <a:lstStyle/>
+          <a:p>
+            <a:endParaRPr lang="en-US"/>
+          </a:p>
+        </p:txBody>
       </p:sp>
       <p:sp>
         <p:nvSpPr>
@@ -2283,11 +2063,11 @@
           </a:bodyPr>
           <a:lstStyle/>
           <a:p>
-            <a:pPr algn="l" indent="0" marL="0">
-              <a:buNone/>
-            </a:pPr>
-            <a:r>
-              <a:rPr lang="en-US" sz="700" spc="1" kern="0" dirty="0">
+            <a:pPr marL="0" indent="0" algn="l">
+              <a:buNone/>
+            </a:pPr>
+            <a:r>
+              <a:rPr lang="en-US" sz="700" kern="0" spc="1" dirty="0">
                 <a:solidFill>
                   <a:srgbClr val="1D9E75"/>
                 </a:solidFill>
@@ -2324,14 +2104,14 @@
           </a:bodyPr>
           <a:lstStyle/>
           <a:p>
-            <a:pPr algn="l" indent="0" marL="0">
+            <a:pPr marL="0" indent="0" algn="l">
               <a:lnSpc>
                 <a:spcPct val="88000"/>
               </a:lnSpc>
               <a:buNone/>
             </a:pPr>
             <a:r>
-              <a:rPr lang="en-US" sz="2600" spc="-1" kern="0" dirty="0">
+              <a:rPr lang="en-US" sz="2600" kern="0" spc="-1" dirty="0">
                 <a:solidFill>
                   <a:srgbClr val="F5F4EF"/>
                 </a:solidFill>
@@ -2368,7 +2148,7 @@
           </a:bodyPr>
           <a:lstStyle/>
           <a:p>
-            <a:pPr algn="l" indent="0" marL="0">
+            <a:pPr marL="0" indent="0" algn="l">
               <a:lnSpc>
                 <a:spcPct val="120000"/>
               </a:lnSpc>
@@ -2412,7 +2192,7 @@
           </a:bodyPr>
           <a:lstStyle/>
           <a:p>
-            <a:pPr algn="l" indent="0" marL="0">
+            <a:pPr marL="0" indent="0" algn="l">
               <a:lnSpc>
                 <a:spcPct val="120000"/>
               </a:lnSpc>
@@ -2459,17 +2239,24 @@
             <a:prstDash val="solid"/>
           </a:ln>
         </p:spPr>
+        <p:txBody>
+          <a:bodyPr/>
+          <a:lstStyle/>
+          <a:p>
+            <a:endParaRPr lang="en-US"/>
+          </a:p>
+        </p:txBody>
       </p:sp>
       <p:pic>
         <p:nvPicPr>
-          <p:cNvPr id="9" name="Image 1" descr="preencoded.png">    </p:cNvPr>
+          <p:cNvPr id="9" name="Image 1" descr="preencoded.png"/>
           <p:cNvPicPr>
             <a:picLocks noChangeAspect="1"/>
           </p:cNvPicPr>
           <p:nvPr/>
         </p:nvPicPr>
         <p:blipFill>
-          <a:blip r:embed="rId2"/>
+          <a:blip r:embed="rId4"/>
           <a:stretch>
             <a:fillRect/>
           </a:stretch>
@@ -2511,604 +2298,7 @@
       </p:grpSpPr>
       <p:pic>
         <p:nvPicPr>
-          <p:cNvPr id="2" name="Image 0" descr="preencoded.png">    </p:cNvPr>
-          <p:cNvPicPr>
-            <a:picLocks noChangeAspect="1"/>
-          </p:cNvPicPr>
-          <p:nvPr/>
-        </p:nvPicPr>
-        <p:blipFill>
-          <a:blip r:embed="rId1"/>
-          <a:stretch>
-            <a:fillRect/>
-          </a:stretch>
-        </p:blipFill>
-        <p:spPr>
-          <a:xfrm>
-            <a:off x="0" y="0"/>
-            <a:ext cx="9144000" cy="5143500"/>
-          </a:xfrm>
-          <a:prstGeom prst="rect">
-            <a:avLst/>
-          </a:prstGeom>
-        </p:spPr>
-      </p:pic>
-      <p:sp>
-        <p:nvSpPr>
-          <p:cNvPr id="3" name="Text 0"/>
-          <p:cNvSpPr/>
-          <p:nvPr/>
-        </p:nvSpPr>
-        <p:spPr>
-          <a:xfrm>
-            <a:off x="714375" y="571500"/>
-            <a:ext cx="7715250" cy="492919"/>
-          </a:xfrm>
-          <a:prstGeom prst="rect">
-            <a:avLst/>
-          </a:prstGeom>
-          <a:noFill/>
-          <a:ln/>
-        </p:spPr>
-        <p:txBody>
-          <a:bodyPr wrap="square" lIns="0" tIns="0" rIns="0" bIns="0" rtlCol="0" anchor="t">
-            <a:spAutoFit/>
-          </a:bodyPr>
-          <a:lstStyle/>
-          <a:p>
-            <a:pPr algn="ctr" indent="0" marL="0">
-              <a:buNone/>
-            </a:pPr>
-            <a:r>
-              <a:rPr lang="en-US" sz="3050" spc="-1" kern="0" dirty="0">
-                <a:solidFill>
-                  <a:srgbClr val="F5F4EF"/>
-                </a:solidFill>
-                <a:latin typeface="Fraunces" pitchFamily="34" charset="0"/>
-                <a:ea typeface="Fraunces" pitchFamily="34" charset="-122"/>
-                <a:cs typeface="Fraunces" pitchFamily="34" charset="-120"/>
-              </a:rPr>
-              <a:t>Built with serious infrastructure.</a:t>
-            </a:r>
-            <a:endParaRPr lang="en-US" sz="3050" dirty="0"/>
-          </a:p>
-        </p:txBody>
-      </p:sp>
-      <p:sp>
-        <p:nvSpPr>
-          <p:cNvPr id="4" name="Text 1"/>
-          <p:cNvSpPr/>
-          <p:nvPr/>
-        </p:nvSpPr>
-        <p:spPr>
-          <a:xfrm>
-            <a:off x="714375" y="1171575"/>
-            <a:ext cx="7715250" cy="282178"/>
-          </a:xfrm>
-          <a:prstGeom prst="rect">
-            <a:avLst/>
-          </a:prstGeom>
-          <a:noFill/>
-          <a:ln/>
-        </p:spPr>
-        <p:txBody>
-          <a:bodyPr wrap="square" lIns="0" tIns="0" rIns="0" bIns="0" rtlCol="0" anchor="t">
-            <a:spAutoFit/>
-          </a:bodyPr>
-          <a:lstStyle/>
-          <a:p>
-            <a:pPr algn="ctr" indent="0" marL="0">
-              <a:buNone/>
-            </a:pPr>
-            <a:r>
-              <a:rPr lang="en-US" sz="1700" i="1" dirty="0">
-                <a:solidFill>
-                  <a:srgbClr val="A5A39A"/>
-                </a:solidFill>
-                <a:latin typeface="Fraunces Light" pitchFamily="34" charset="0"/>
-                <a:ea typeface="Fraunces Light" pitchFamily="34" charset="-122"/>
-                <a:cs typeface="Fraunces Light" pitchFamily="34" charset="-120"/>
-              </a:rPr>
-              <a:t>Privacy and messaging, handled by the best.</a:t>
-            </a:r>
-            <a:endParaRPr lang="en-US" sz="1700" dirty="0"/>
-          </a:p>
-        </p:txBody>
-      </p:sp>
-      <p:pic>
-        <p:nvPicPr>
-          <p:cNvPr id="5" name="Image 1" descr="preencoded.png">    </p:cNvPr>
-          <p:cNvPicPr>
-            <a:picLocks noChangeAspect="1"/>
-          </p:cNvPicPr>
-          <p:nvPr/>
-        </p:nvPicPr>
-        <p:blipFill>
-          <a:blip r:embed="rId2"/>
-          <a:stretch>
-            <a:fillRect/>
-          </a:stretch>
-        </p:blipFill>
-        <p:spPr>
-          <a:xfrm>
-            <a:off x="714375" y="1953816"/>
-            <a:ext cx="571500" cy="571500"/>
-          </a:xfrm>
-          <a:prstGeom prst="rect">
-            <a:avLst/>
-          </a:prstGeom>
-        </p:spPr>
-      </p:pic>
-      <p:sp>
-        <p:nvSpPr>
-          <p:cNvPr id="6" name="Text 2"/>
-          <p:cNvSpPr/>
-          <p:nvPr/>
-        </p:nvSpPr>
-        <p:spPr>
-          <a:xfrm>
-            <a:off x="714375" y="2811066"/>
-            <a:ext cx="3643313" cy="248245"/>
-          </a:xfrm>
-          <a:prstGeom prst="rect">
-            <a:avLst/>
-          </a:prstGeom>
-          <a:noFill/>
-          <a:ln/>
-        </p:spPr>
-        <p:txBody>
-          <a:bodyPr wrap="square" lIns="0" tIns="0" rIns="0" bIns="0" rtlCol="0" anchor="t">
-            <a:spAutoFit/>
-          </a:bodyPr>
-          <a:lstStyle/>
-          <a:p>
-            <a:pPr algn="l" indent="0" marL="0">
-              <a:buNone/>
-            </a:pPr>
-            <a:r>
-              <a:rPr lang="en-US" sz="1500" dirty="0">
-                <a:solidFill>
-                  <a:srgbClr val="FF5A1F"/>
-                </a:solidFill>
-                <a:latin typeface="Fraunces" pitchFamily="34" charset="0"/>
-                <a:ea typeface="Fraunces" pitchFamily="34" charset="-122"/>
-                <a:cs typeface="Fraunces" pitchFamily="34" charset="-120"/>
-              </a:rPr>
-              <a:t>Privacy Infrastructure for AI</a:t>
-            </a:r>
-            <a:endParaRPr lang="en-US" sz="1500" dirty="0"/>
-          </a:p>
-        </p:txBody>
-      </p:sp>
-      <p:sp>
-        <p:nvSpPr>
-          <p:cNvPr id="7" name="Text 3"/>
-          <p:cNvSpPr/>
-          <p:nvPr/>
-        </p:nvSpPr>
-        <p:spPr>
-          <a:xfrm>
-            <a:off x="714375" y="3130748"/>
-            <a:ext cx="3643313" cy="185738"/>
-          </a:xfrm>
-          <a:prstGeom prst="rect">
-            <a:avLst/>
-          </a:prstGeom>
-          <a:noFill/>
-          <a:ln/>
-        </p:spPr>
-        <p:txBody>
-          <a:bodyPr wrap="square" lIns="127508" tIns="0" rIns="0" bIns="0" rtlCol="0" anchor="t">
-            <a:spAutoFit/>
-          </a:bodyPr>
-          <a:lstStyle/>
-          <a:p>
-            <a:pPr algn="l" indent="0" marL="0">
-              <a:buNone/>
-            </a:pPr>
-            <a:r>
-              <a:rPr lang="en-US" sz="1050" i="1" dirty="0">
-                <a:solidFill>
-                  <a:srgbClr val="F5F4EF"/>
-                </a:solidFill>
-                <a:latin typeface="DM Sans" pitchFamily="34" charset="0"/>
-                <a:ea typeface="DM Sans" pitchFamily="34" charset="-122"/>
-                <a:cs typeface="DM Sans" pitchFamily="34" charset="-120"/>
-              </a:rPr>
-              <a:t>"Privacy as infrastructure. Not a pinky promise."</a:t>
-            </a:r>
-            <a:endParaRPr lang="en-US" sz="1050" dirty="0"/>
-          </a:p>
-        </p:txBody>
-      </p:sp>
-      <p:sp>
-        <p:nvSpPr>
-          <p:cNvPr id="8" name="Text 4"/>
-          <p:cNvSpPr/>
-          <p:nvPr/>
-        </p:nvSpPr>
-        <p:spPr>
-          <a:xfrm>
-            <a:off x="714375" y="3495080"/>
-            <a:ext cx="3643313" cy="192881"/>
-          </a:xfrm>
-          <a:prstGeom prst="rect">
-            <a:avLst/>
-          </a:prstGeom>
-          <a:noFill/>
-          <a:ln/>
-        </p:spPr>
-        <p:txBody>
-          <a:bodyPr wrap="none" lIns="170053" tIns="0" rIns="0" bIns="0" rtlCol="0" anchor="t">
-            <a:spAutoFit/>
-          </a:bodyPr>
-          <a:lstStyle/>
-          <a:p>
-            <a:pPr algn="l" indent="0" marL="0">
-              <a:lnSpc>
-                <a:spcPct val="120000"/>
-              </a:lnSpc>
-              <a:buNone/>
-            </a:pPr>
-            <a:r>
-              <a:rPr lang="en-US" sz="900" b="1" dirty="0">
-                <a:solidFill>
-                  <a:srgbClr val="A5A39A"/>
-                </a:solidFill>
-                <a:latin typeface="DM Sans Bold" pitchFamily="34" charset="0"/>
-                <a:ea typeface="DM Sans Bold" pitchFamily="34" charset="-122"/>
-                <a:cs typeface="DM Sans Bold" pitchFamily="34" charset="-120"/>
-              </a:rPr>
-              <a:t>PasskeyID</a:t>
-            </a:r>
-            <a:r>
-              <a:rPr lang="en-US" sz="950" dirty="0">
-                <a:solidFill>
-                  <a:srgbClr val="A5A39A"/>
-                </a:solidFill>
-                <a:latin typeface="DM Sans" pitchFamily="34" charset="0"/>
-                <a:ea typeface="DM Sans" pitchFamily="34" charset="-122"/>
-                <a:cs typeface="DM Sans" pitchFamily="34" charset="-120"/>
-              </a:rPr>
-              <a:t> authentication via Face ID / Touch ID</a:t>
-            </a:r>
-            <a:endParaRPr lang="en-US" sz="900" dirty="0"/>
-          </a:p>
-        </p:txBody>
-      </p:sp>
-      <p:sp>
-        <p:nvSpPr>
-          <p:cNvPr id="9" name="Text 5"/>
-          <p:cNvSpPr/>
-          <p:nvPr/>
-        </p:nvSpPr>
-        <p:spPr>
-          <a:xfrm>
-            <a:off x="714375" y="3795117"/>
-            <a:ext cx="3643313" cy="192881"/>
-          </a:xfrm>
-          <a:prstGeom prst="rect">
-            <a:avLst/>
-          </a:prstGeom>
-          <a:noFill/>
-          <a:ln/>
-        </p:spPr>
-        <p:txBody>
-          <a:bodyPr wrap="none" lIns="170053" tIns="0" rIns="0" bIns="0" rtlCol="0" anchor="t">
-            <a:spAutoFit/>
-          </a:bodyPr>
-          <a:lstStyle/>
-          <a:p>
-            <a:pPr algn="l" indent="0" marL="0">
-              <a:lnSpc>
-                <a:spcPct val="120000"/>
-              </a:lnSpc>
-              <a:buNone/>
-            </a:pPr>
-            <a:r>
-              <a:rPr lang="en-US" sz="900" b="1" dirty="0">
-                <a:solidFill>
-                  <a:srgbClr val="A5A39A"/>
-                </a:solidFill>
-                <a:latin typeface="DM Sans Bold" pitchFamily="34" charset="0"/>
-                <a:ea typeface="DM Sans Bold" pitchFamily="34" charset="-122"/>
-                <a:cs typeface="DM Sans Bold" pitchFamily="34" charset="-120"/>
-              </a:rPr>
-              <a:t>AES-256-GCM</a:t>
-            </a:r>
-            <a:r>
-              <a:rPr lang="en-US" sz="950" dirty="0">
-                <a:solidFill>
-                  <a:srgbClr val="A5A39A"/>
-                </a:solidFill>
-                <a:latin typeface="DM Sans" pitchFamily="34" charset="0"/>
-                <a:ea typeface="DM Sans" pitchFamily="34" charset="-122"/>
-                <a:cs typeface="DM Sans" pitchFamily="34" charset="-120"/>
-              </a:rPr>
-              <a:t> encrypted memory for all wiki data</a:t>
-            </a:r>
-            <a:endParaRPr lang="en-US" sz="900" dirty="0"/>
-          </a:p>
-        </p:txBody>
-      </p:sp>
-      <p:sp>
-        <p:nvSpPr>
-          <p:cNvPr id="10" name="Text 6"/>
-          <p:cNvSpPr/>
-          <p:nvPr/>
-        </p:nvSpPr>
-        <p:spPr>
-          <a:xfrm>
-            <a:off x="714375" y="4095155"/>
-            <a:ext cx="3643313" cy="385763"/>
-          </a:xfrm>
-          <a:prstGeom prst="rect">
-            <a:avLst/>
-          </a:prstGeom>
-          <a:noFill/>
-          <a:ln/>
-        </p:spPr>
-        <p:txBody>
-          <a:bodyPr wrap="square" lIns="170053" tIns="0" rIns="0" bIns="0" rtlCol="0" anchor="t">
-            <a:spAutoFit/>
-          </a:bodyPr>
-          <a:lstStyle/>
-          <a:p>
-            <a:pPr algn="l" indent="0" marL="0">
-              <a:lnSpc>
-                <a:spcPct val="120000"/>
-              </a:lnSpc>
-              <a:buNone/>
-            </a:pPr>
-            <a:r>
-              <a:rPr lang="en-US" sz="900" b="1" dirty="0">
-                <a:solidFill>
-                  <a:srgbClr val="A5A39A"/>
-                </a:solidFill>
-                <a:latin typeface="DM Sans Bold" pitchFamily="34" charset="0"/>
-                <a:ea typeface="DM Sans Bold" pitchFamily="34" charset="-122"/>
-                <a:cs typeface="DM Sans Bold" pitchFamily="34" charset="-120"/>
-              </a:rPr>
-              <a:t>PrivateLLM</a:t>
-            </a:r>
-            <a:r>
-              <a:rPr lang="en-US" sz="950" dirty="0">
-                <a:solidFill>
-                  <a:srgbClr val="A5A39A"/>
-                </a:solidFill>
-                <a:latin typeface="DM Sans" pitchFamily="34" charset="0"/>
-                <a:ea typeface="DM Sans" pitchFamily="34" charset="-122"/>
-                <a:cs typeface="DM Sans" pitchFamily="34" charset="-120"/>
-              </a:rPr>
-              <a:t> inference inside H100 Trusted Execution Environments</a:t>
-            </a:r>
-            <a:endParaRPr lang="en-US" sz="900" dirty="0"/>
-          </a:p>
-        </p:txBody>
-      </p:sp>
-      <p:sp>
-        <p:nvSpPr>
-          <p:cNvPr id="11" name="Text 7"/>
-          <p:cNvSpPr/>
-          <p:nvPr/>
-        </p:nvSpPr>
-        <p:spPr>
-          <a:xfrm>
-            <a:off x="714375" y="4588073"/>
-            <a:ext cx="3643313" cy="192881"/>
-          </a:xfrm>
-          <a:prstGeom prst="rect">
-            <a:avLst/>
-          </a:prstGeom>
-          <a:noFill/>
-          <a:ln/>
-        </p:spPr>
-        <p:txBody>
-          <a:bodyPr wrap="none" lIns="170053" tIns="0" rIns="0" bIns="0" rtlCol="0" anchor="t">
-            <a:spAutoFit/>
-          </a:bodyPr>
-          <a:lstStyle/>
-          <a:p>
-            <a:pPr algn="l" indent="0" marL="0">
-              <a:lnSpc>
-                <a:spcPct val="120000"/>
-              </a:lnSpc>
-              <a:buNone/>
-            </a:pPr>
-            <a:r>
-              <a:rPr lang="en-US" sz="950" dirty="0">
-                <a:solidFill>
-                  <a:srgbClr val="A5A39A"/>
-                </a:solidFill>
-                <a:latin typeface="DM Sans" pitchFamily="34" charset="0"/>
-                <a:ea typeface="DM Sans" pitchFamily="34" charset="-122"/>
-                <a:cs typeface="DM Sans" pitchFamily="34" charset="-120"/>
-              </a:rPr>
-              <a:t>SOC 2 Type II certified architecture</a:t>
-            </a:r>
-            <a:endParaRPr lang="en-US" sz="950" dirty="0"/>
-          </a:p>
-        </p:txBody>
-      </p:sp>
-      <p:sp>
-        <p:nvSpPr>
-          <p:cNvPr id="12" name="Text 8"/>
-          <p:cNvSpPr/>
-          <p:nvPr/>
-        </p:nvSpPr>
-        <p:spPr>
-          <a:xfrm>
-            <a:off x="714375" y="3495080"/>
-            <a:ext cx="46434" cy="192881"/>
-          </a:xfrm>
-          <a:prstGeom prst="rect">
-            <a:avLst/>
-          </a:prstGeom>
-          <a:noFill/>
-          <a:ln/>
-        </p:spPr>
-        <p:txBody>
-          <a:bodyPr wrap="none" lIns="0" tIns="0" rIns="0" bIns="0" rtlCol="0" anchor="t">
-            <a:spAutoFit/>
-          </a:bodyPr>
-          <a:lstStyle/>
-          <a:p>
-            <a:pPr algn="l" indent="0" marL="0">
-              <a:lnSpc>
-                <a:spcPct val="120000"/>
-              </a:lnSpc>
-              <a:buNone/>
-            </a:pPr>
-            <a:r>
-              <a:rPr lang="en-US" sz="950" dirty="0">
-                <a:solidFill>
-                  <a:srgbClr val="F5F4EF"/>
-                </a:solidFill>
-                <a:latin typeface="DM Sans" pitchFamily="34" charset="0"/>
-                <a:ea typeface="DM Sans" pitchFamily="34" charset="-122"/>
-                <a:cs typeface="DM Sans" pitchFamily="34" charset="-120"/>
-              </a:rPr>
-              <a:t>•</a:t>
-            </a:r>
-            <a:endParaRPr lang="en-US" sz="950" dirty="0"/>
-          </a:p>
-        </p:txBody>
-      </p:sp>
-      <p:sp>
-        <p:nvSpPr>
-          <p:cNvPr id="13" name="Text 9"/>
-          <p:cNvSpPr/>
-          <p:nvPr/>
-        </p:nvSpPr>
-        <p:spPr>
-          <a:xfrm>
-            <a:off x="714375" y="3795117"/>
-            <a:ext cx="46434" cy="192881"/>
-          </a:xfrm>
-          <a:prstGeom prst="rect">
-            <a:avLst/>
-          </a:prstGeom>
-          <a:noFill/>
-          <a:ln/>
-        </p:spPr>
-        <p:txBody>
-          <a:bodyPr wrap="none" lIns="0" tIns="0" rIns="0" bIns="0" rtlCol="0" anchor="t">
-            <a:spAutoFit/>
-          </a:bodyPr>
-          <a:lstStyle/>
-          <a:p>
-            <a:pPr algn="l" indent="0" marL="0">
-              <a:lnSpc>
-                <a:spcPct val="120000"/>
-              </a:lnSpc>
-              <a:buNone/>
-            </a:pPr>
-            <a:r>
-              <a:rPr lang="en-US" sz="950" dirty="0">
-                <a:solidFill>
-                  <a:srgbClr val="F5F4EF"/>
-                </a:solidFill>
-                <a:latin typeface="DM Sans" pitchFamily="34" charset="0"/>
-                <a:ea typeface="DM Sans" pitchFamily="34" charset="-122"/>
-                <a:cs typeface="DM Sans" pitchFamily="34" charset="-120"/>
-              </a:rPr>
-              <a:t>•</a:t>
-            </a:r>
-            <a:endParaRPr lang="en-US" sz="950" dirty="0"/>
-          </a:p>
-        </p:txBody>
-      </p:sp>
-      <p:sp>
-        <p:nvSpPr>
-          <p:cNvPr id="14" name="Text 10"/>
-          <p:cNvSpPr/>
-          <p:nvPr/>
-        </p:nvSpPr>
-        <p:spPr>
-          <a:xfrm>
-            <a:off x="714375" y="4095155"/>
-            <a:ext cx="46434" cy="192881"/>
-          </a:xfrm>
-          <a:prstGeom prst="rect">
-            <a:avLst/>
-          </a:prstGeom>
-          <a:noFill/>
-          <a:ln/>
-        </p:spPr>
-        <p:txBody>
-          <a:bodyPr wrap="none" lIns="0" tIns="0" rIns="0" bIns="0" rtlCol="0" anchor="t">
-            <a:spAutoFit/>
-          </a:bodyPr>
-          <a:lstStyle/>
-          <a:p>
-            <a:pPr algn="l" indent="0" marL="0">
-              <a:lnSpc>
-                <a:spcPct val="120000"/>
-              </a:lnSpc>
-              <a:buNone/>
-            </a:pPr>
-            <a:r>
-              <a:rPr lang="en-US" sz="950" dirty="0">
-                <a:solidFill>
-                  <a:srgbClr val="F5F4EF"/>
-                </a:solidFill>
-                <a:latin typeface="DM Sans" pitchFamily="34" charset="0"/>
-                <a:ea typeface="DM Sans" pitchFamily="34" charset="-122"/>
-                <a:cs typeface="DM Sans" pitchFamily="34" charset="-120"/>
-              </a:rPr>
-              <a:t>•</a:t>
-            </a:r>
-            <a:endParaRPr lang="en-US" sz="950" dirty="0"/>
-          </a:p>
-        </p:txBody>
-      </p:sp>
-      <p:sp>
-        <p:nvSpPr>
-          <p:cNvPr id="15" name="Text 11"/>
-          <p:cNvSpPr/>
-          <p:nvPr/>
-        </p:nvSpPr>
-        <p:spPr>
-          <a:xfrm>
-            <a:off x="714375" y="4588073"/>
-            <a:ext cx="46434" cy="192881"/>
-          </a:xfrm>
-          <a:prstGeom prst="rect">
-            <a:avLst/>
-          </a:prstGeom>
-          <a:noFill/>
-          <a:ln/>
-        </p:spPr>
-        <p:txBody>
-          <a:bodyPr wrap="none" lIns="0" tIns="0" rIns="0" bIns="0" rtlCol="0" anchor="t">
-            <a:spAutoFit/>
-          </a:bodyPr>
-          <a:lstStyle/>
-          <a:p>
-            <a:pPr algn="l" indent="0" marL="0">
-              <a:lnSpc>
-                <a:spcPct val="120000"/>
-              </a:lnSpc>
-              <a:buNone/>
-            </a:pPr>
-            <a:r>
-              <a:rPr lang="en-US" sz="950" dirty="0">
-                <a:solidFill>
-                  <a:srgbClr val="F5F4EF"/>
-                </a:solidFill>
-                <a:latin typeface="DM Sans" pitchFamily="34" charset="0"/>
-                <a:ea typeface="DM Sans" pitchFamily="34" charset="-122"/>
-                <a:cs typeface="DM Sans" pitchFamily="34" charset="-120"/>
-              </a:rPr>
-              <a:t>•</a:t>
-            </a:r>
-            <a:endParaRPr lang="en-US" sz="950" dirty="0"/>
-          </a:p>
-        </p:txBody>
-      </p:sp>
-      <p:pic>
-        <p:nvPicPr>
-          <p:cNvPr id="16" name="Image 2" descr="preencoded.png">    </p:cNvPr>
+          <p:cNvPr id="2" name="Image 0" descr="preencoded.png"/>
           <p:cNvPicPr>
             <a:picLocks noChangeAspect="1"/>
           </p:cNvPicPr>
@@ -3122,8 +2312,8 @@
         </p:blipFill>
         <p:spPr>
           <a:xfrm>
-            <a:off x="4786313" y="1918097"/>
-            <a:ext cx="642938" cy="642938"/>
+            <a:off x="0" y="0"/>
+            <a:ext cx="9144000" cy="5143500"/>
           </a:xfrm>
           <a:prstGeom prst="rect">
             <a:avLst/>
@@ -3132,14 +2322,14 @@
       </p:pic>
       <p:sp>
         <p:nvSpPr>
-          <p:cNvPr id="17" name="Text 12"/>
-          <p:cNvSpPr/>
-          <p:nvPr/>
-        </p:nvSpPr>
-        <p:spPr>
-          <a:xfrm>
-            <a:off x="4786313" y="2811066"/>
-            <a:ext cx="3643313" cy="248245"/>
+          <p:cNvPr id="3" name="Text 0"/>
+          <p:cNvSpPr/>
+          <p:nvPr/>
+        </p:nvSpPr>
+        <p:spPr>
+          <a:xfrm>
+            <a:off x="714375" y="571500"/>
+            <a:ext cx="7715250" cy="492919"/>
           </a:xfrm>
           <a:prstGeom prst="rect">
             <a:avLst/>
@@ -3153,19 +2343,125 @@
           </a:bodyPr>
           <a:lstStyle/>
           <a:p>
-            <a:pPr algn="l" indent="0" marL="0">
-              <a:buNone/>
-            </a:pPr>
-            <a:r>
-              <a:rPr lang="en-US" sz="1500" dirty="0">
-                <a:solidFill>
-                  <a:srgbClr val="378ADD"/>
+            <a:pPr marL="0" indent="0" algn="ctr">
+              <a:buNone/>
+            </a:pPr>
+            <a:r>
+              <a:rPr lang="en-US" sz="3050" kern="0" spc="-1" dirty="0">
+                <a:solidFill>
+                  <a:srgbClr val="F5F4EF"/>
                 </a:solidFill>
                 <a:latin typeface="Fraunces" pitchFamily="34" charset="0"/>
                 <a:ea typeface="Fraunces" pitchFamily="34" charset="-122"/>
                 <a:cs typeface="Fraunces" pitchFamily="34" charset="-120"/>
               </a:rPr>
-              <a:t>iMessage &amp; SMS for AI Agents</a:t>
+              <a:t>Built with serious infrastructure.</a:t>
+            </a:r>
+            <a:endParaRPr lang="en-US" sz="3050" dirty="0"/>
+          </a:p>
+        </p:txBody>
+      </p:sp>
+      <p:sp>
+        <p:nvSpPr>
+          <p:cNvPr id="4" name="Text 1"/>
+          <p:cNvSpPr/>
+          <p:nvPr/>
+        </p:nvSpPr>
+        <p:spPr>
+          <a:xfrm>
+            <a:off x="714375" y="1171575"/>
+            <a:ext cx="7715250" cy="282178"/>
+          </a:xfrm>
+          <a:prstGeom prst="rect">
+            <a:avLst/>
+          </a:prstGeom>
+          <a:noFill/>
+          <a:ln/>
+        </p:spPr>
+        <p:txBody>
+          <a:bodyPr wrap="square" lIns="0" tIns="0" rIns="0" bIns="0" rtlCol="0" anchor="t">
+            <a:spAutoFit/>
+          </a:bodyPr>
+          <a:lstStyle/>
+          <a:p>
+            <a:pPr marL="0" indent="0" algn="ctr">
+              <a:buNone/>
+            </a:pPr>
+            <a:r>
+              <a:rPr lang="en-US" sz="1700" i="1" dirty="0">
+                <a:solidFill>
+                  <a:srgbClr val="A5A39A"/>
+                </a:solidFill>
+                <a:latin typeface="Fraunces Light" pitchFamily="34" charset="0"/>
+                <a:ea typeface="Fraunces Light" pitchFamily="34" charset="-122"/>
+                <a:cs typeface="Fraunces Light" pitchFamily="34" charset="-120"/>
+              </a:rPr>
+              <a:t>Privacy and messaging, handled by the best.</a:t>
+            </a:r>
+            <a:endParaRPr lang="en-US" sz="1700" dirty="0"/>
+          </a:p>
+        </p:txBody>
+      </p:sp>
+      <p:pic>
+        <p:nvPicPr>
+          <p:cNvPr id="5" name="Image 1" descr="preencoded.png"/>
+          <p:cNvPicPr>
+            <a:picLocks noChangeAspect="1"/>
+          </p:cNvPicPr>
+          <p:nvPr/>
+        </p:nvPicPr>
+        <p:blipFill>
+          <a:blip r:embed="rId4"/>
+          <a:stretch>
+            <a:fillRect/>
+          </a:stretch>
+        </p:blipFill>
+        <p:spPr>
+          <a:xfrm>
+            <a:off x="714375" y="1953816"/>
+            <a:ext cx="571500" cy="571500"/>
+          </a:xfrm>
+          <a:prstGeom prst="rect">
+            <a:avLst/>
+          </a:prstGeom>
+        </p:spPr>
+      </p:pic>
+      <p:sp>
+        <p:nvSpPr>
+          <p:cNvPr id="6" name="Text 2"/>
+          <p:cNvSpPr/>
+          <p:nvPr/>
+        </p:nvSpPr>
+        <p:spPr>
+          <a:xfrm>
+            <a:off x="714375" y="2811066"/>
+            <a:ext cx="3643313" cy="248245"/>
+          </a:xfrm>
+          <a:prstGeom prst="rect">
+            <a:avLst/>
+          </a:prstGeom>
+          <a:noFill/>
+          <a:ln/>
+        </p:spPr>
+        <p:txBody>
+          <a:bodyPr wrap="square" lIns="0" tIns="0" rIns="0" bIns="0" rtlCol="0" anchor="t">
+            <a:spAutoFit/>
+          </a:bodyPr>
+          <a:lstStyle/>
+          <a:p>
+            <a:pPr marL="0" indent="0" algn="l">
+              <a:buNone/>
+            </a:pPr>
+            <a:r>
+              <a:rPr lang="en-US" sz="1500" dirty="0">
+                <a:solidFill>
+                  <a:srgbClr val="FF5A1F"/>
+                </a:solidFill>
+                <a:latin typeface="Fraunces" pitchFamily="34" charset="0"/>
+                <a:ea typeface="Fraunces" pitchFamily="34" charset="-122"/>
+                <a:cs typeface="Fraunces" pitchFamily="34" charset="-120"/>
+              </a:rPr>
+              <a:t>Privacy Infrastructure for AI</a:t>
             </a:r>
             <a:endParaRPr lang="en-US" sz="1500" dirty="0"/>
           </a:p>
@@ -3173,13 +2469,13 @@
       </p:sp>
       <p:sp>
         <p:nvSpPr>
-          <p:cNvPr id="18" name="Text 13"/>
-          <p:cNvSpPr/>
-          <p:nvPr/>
-        </p:nvSpPr>
-        <p:spPr>
-          <a:xfrm>
-            <a:off x="4786313" y="3130748"/>
+          <p:cNvPr id="7" name="Text 3"/>
+          <p:cNvSpPr/>
+          <p:nvPr/>
+        </p:nvSpPr>
+        <p:spPr>
+          <a:xfrm>
+            <a:off x="714375" y="3130748"/>
             <a:ext cx="3643313" cy="185738"/>
           </a:xfrm>
           <a:prstGeom prst="rect">
@@ -3194,7 +2490,7 @@
           </a:bodyPr>
           <a:lstStyle/>
           <a:p>
-            <a:pPr algn="l" indent="0" marL="0">
+            <a:pPr marL="0" indent="0" algn="l">
               <a:buNone/>
             </a:pPr>
             <a:r>
@@ -3206,7 +2502,7 @@
                 <a:ea typeface="DM Sans" pitchFamily="34" charset="-122"/>
                 <a:cs typeface="DM Sans" pitchFamily="34" charset="-120"/>
               </a:rPr>
-              <a:t>"The same infrastructure that powers Poke."</a:t>
+              <a:t>"Privacy as infrastructure. Not a pinky promise."</a:t>
             </a:r>
             <a:endParaRPr lang="en-US" sz="1050" dirty="0"/>
           </a:p>
@@ -3214,13 +2510,13 @@
       </p:sp>
       <p:sp>
         <p:nvSpPr>
-          <p:cNvPr id="19" name="Text 14"/>
-          <p:cNvSpPr/>
-          <p:nvPr/>
-        </p:nvSpPr>
-        <p:spPr>
-          <a:xfrm>
-            <a:off x="4786313" y="3495080"/>
+          <p:cNvPr id="8" name="Text 4"/>
+          <p:cNvSpPr/>
+          <p:nvPr/>
+        </p:nvSpPr>
+        <p:spPr>
+          <a:xfrm>
+            <a:off x="714375" y="3495080"/>
             <a:ext cx="3643313" cy="192881"/>
           </a:xfrm>
           <a:prstGeom prst="rect">
@@ -3235,7 +2531,7 @@
           </a:bodyPr>
           <a:lstStyle/>
           <a:p>
-            <a:pPr algn="l" indent="0" marL="0">
+            <a:pPr marL="0" indent="0" algn="l">
               <a:lnSpc>
                 <a:spcPct val="120000"/>
               </a:lnSpc>
@@ -3250,7 +2546,7 @@
                 <a:ea typeface="DM Sans Bold" pitchFamily="34" charset="-122"/>
                 <a:cs typeface="DM Sans Bold" pitchFamily="34" charset="-120"/>
               </a:rPr>
-              <a:t>Native iMessage</a:t>
+              <a:t>PasskeyID</a:t>
             </a:r>
             <a:r>
               <a:rPr lang="en-US" sz="950" dirty="0">
@@ -3261,7 +2557,7 @@
                 <a:ea typeface="DM Sans" pitchFamily="34" charset="-122"/>
                 <a:cs typeface="DM Sans" pitchFamily="34" charset="-120"/>
               </a:rPr>
-              <a:t>, RCS, and SMS delivery</a:t>
+              <a:t> authentication via Face ID / Touch ID</a:t>
             </a:r>
             <a:endParaRPr lang="en-US" sz="900" dirty="0"/>
           </a:p>
@@ -3269,13 +2565,13 @@
       </p:sp>
       <p:sp>
         <p:nvSpPr>
-          <p:cNvPr id="20" name="Text 15"/>
-          <p:cNvSpPr/>
-          <p:nvPr/>
-        </p:nvSpPr>
-        <p:spPr>
-          <a:xfrm>
-            <a:off x="4786313" y="3795117"/>
+          <p:cNvPr id="9" name="Text 5"/>
+          <p:cNvSpPr/>
+          <p:nvPr/>
+        </p:nvSpPr>
+        <p:spPr>
+          <a:xfrm>
+            <a:off x="714375" y="3795117"/>
             <a:ext cx="3643313" cy="192881"/>
           </a:xfrm>
           <a:prstGeom prst="rect">
@@ -3290,13 +2586,24 @@
           </a:bodyPr>
           <a:lstStyle/>
           <a:p>
-            <a:pPr algn="l" indent="0" marL="0">
+            <a:pPr marL="0" indent="0" algn="l">
               <a:lnSpc>
                 <a:spcPct val="120000"/>
               </a:lnSpc>
               <a:buNone/>
             </a:pPr>
             <a:r>
+              <a:rPr lang="en-US" sz="900" b="1" dirty="0">
+                <a:solidFill>
+                  <a:srgbClr val="A5A39A"/>
+                </a:solidFill>
+                <a:latin typeface="DM Sans Bold" pitchFamily="34" charset="0"/>
+                <a:ea typeface="DM Sans Bold" pitchFamily="34" charset="-122"/>
+                <a:cs typeface="DM Sans Bold" pitchFamily="34" charset="-120"/>
+              </a:rPr>
+              <a:t>AES-256-GCM</a:t>
+            </a:r>
+            <a:r>
               <a:rPr lang="en-US" sz="950" dirty="0">
                 <a:solidFill>
                   <a:srgbClr val="A5A39A"/>
@@ -3305,8 +2612,41 @@
                 <a:ea typeface="DM Sans" pitchFamily="34" charset="-122"/>
                 <a:cs typeface="DM Sans" pitchFamily="34" charset="-120"/>
               </a:rPr>
-              <a:t>Trusted by </a:t>
-            </a:r>
+              <a:t> encrypted memory for all wiki data</a:t>
+            </a:r>
+            <a:endParaRPr lang="en-US" sz="900" dirty="0"/>
+          </a:p>
+        </p:txBody>
+      </p:sp>
+      <p:sp>
+        <p:nvSpPr>
+          <p:cNvPr id="10" name="Text 6"/>
+          <p:cNvSpPr/>
+          <p:nvPr/>
+        </p:nvSpPr>
+        <p:spPr>
+          <a:xfrm>
+            <a:off x="714375" y="4095155"/>
+            <a:ext cx="3643313" cy="385763"/>
+          </a:xfrm>
+          <a:prstGeom prst="rect">
+            <a:avLst/>
+          </a:prstGeom>
+          <a:noFill/>
+          <a:ln/>
+        </p:spPr>
+        <p:txBody>
+          <a:bodyPr wrap="square" lIns="170053" tIns="0" rIns="0" bIns="0" rtlCol="0" anchor="t">
+            <a:spAutoFit/>
+          </a:bodyPr>
+          <a:lstStyle/>
+          <a:p>
+            <a:pPr marL="0" indent="0" algn="l">
+              <a:lnSpc>
+                <a:spcPct val="120000"/>
+              </a:lnSpc>
+              <a:buNone/>
+            </a:pPr>
             <a:r>
               <a:rPr lang="en-US" sz="900" b="1" dirty="0">
                 <a:solidFill>
@@ -3316,7 +2656,7 @@
                 <a:ea typeface="DM Sans Bold" pitchFamily="34" charset="-122"/>
                 <a:cs typeface="DM Sans Bold" pitchFamily="34" charset="-120"/>
               </a:rPr>
-              <a:t>50,000+ teams</a:t>
+              <a:t>PrivateLLM</a:t>
             </a:r>
             <a:r>
               <a:rPr lang="en-US" sz="950" dirty="0">
@@ -3327,36 +2667,36 @@
                 <a:ea typeface="DM Sans" pitchFamily="34" charset="-122"/>
                 <a:cs typeface="DM Sans" pitchFamily="34" charset="-120"/>
               </a:rPr>
-              <a:t> on Linq Blue</a:t>
-            </a:r>
-            <a:endParaRPr lang="en-US" sz="950" dirty="0"/>
-          </a:p>
-        </p:txBody>
-      </p:sp>
-      <p:sp>
-        <p:nvSpPr>
-          <p:cNvPr id="21" name="Text 16"/>
-          <p:cNvSpPr/>
-          <p:nvPr/>
-        </p:nvSpPr>
-        <p:spPr>
-          <a:xfrm>
-            <a:off x="4786313" y="4095155"/>
-            <a:ext cx="3643313" cy="385763"/>
-          </a:xfrm>
-          <a:prstGeom prst="rect">
-            <a:avLst/>
-          </a:prstGeom>
-          <a:noFill/>
-          <a:ln/>
-        </p:spPr>
-        <p:txBody>
-          <a:bodyPr wrap="square" lIns="170053" tIns="0" rIns="0" bIns="0" rtlCol="0" anchor="t">
-            <a:spAutoFit/>
-          </a:bodyPr>
-          <a:lstStyle/>
-          <a:p>
-            <a:pPr algn="l" indent="0" marL="0">
+              <a:t> inference inside H100 Trusted Execution Environments</a:t>
+            </a:r>
+            <a:endParaRPr lang="en-US" sz="900" dirty="0"/>
+          </a:p>
+        </p:txBody>
+      </p:sp>
+      <p:sp>
+        <p:nvSpPr>
+          <p:cNvPr id="11" name="Text 7"/>
+          <p:cNvSpPr/>
+          <p:nvPr/>
+        </p:nvSpPr>
+        <p:spPr>
+          <a:xfrm>
+            <a:off x="714375" y="4588073"/>
+            <a:ext cx="3643313" cy="192881"/>
+          </a:xfrm>
+          <a:prstGeom prst="rect">
+            <a:avLst/>
+          </a:prstGeom>
+          <a:noFill/>
+          <a:ln/>
+        </p:spPr>
+        <p:txBody>
+          <a:bodyPr wrap="none" lIns="170053" tIns="0" rIns="0" bIns="0" rtlCol="0" anchor="t">
+            <a:spAutoFit/>
+          </a:bodyPr>
+          <a:lstStyle/>
+          <a:p>
+            <a:pPr marL="0" indent="0" algn="l">
               <a:lnSpc>
                 <a:spcPct val="120000"/>
               </a:lnSpc>
@@ -3371,6 +2711,453 @@
                 <a:ea typeface="DM Sans" pitchFamily="34" charset="-122"/>
                 <a:cs typeface="DM Sans" pitchFamily="34" charset="-120"/>
               </a:rPr>
+              <a:t>SOC 2 Type II certified architecture</a:t>
+            </a:r>
+            <a:endParaRPr lang="en-US" sz="950" dirty="0"/>
+          </a:p>
+        </p:txBody>
+      </p:sp>
+      <p:sp>
+        <p:nvSpPr>
+          <p:cNvPr id="12" name="Text 8"/>
+          <p:cNvSpPr/>
+          <p:nvPr/>
+        </p:nvSpPr>
+        <p:spPr>
+          <a:xfrm>
+            <a:off x="714375" y="3495080"/>
+            <a:ext cx="46434" cy="192881"/>
+          </a:xfrm>
+          <a:prstGeom prst="rect">
+            <a:avLst/>
+          </a:prstGeom>
+          <a:noFill/>
+          <a:ln/>
+        </p:spPr>
+        <p:txBody>
+          <a:bodyPr wrap="none" lIns="0" tIns="0" rIns="0" bIns="0" rtlCol="0" anchor="t">
+            <a:spAutoFit/>
+          </a:bodyPr>
+          <a:lstStyle/>
+          <a:p>
+            <a:pPr marL="0" indent="0" algn="l">
+              <a:lnSpc>
+                <a:spcPct val="120000"/>
+              </a:lnSpc>
+              <a:buNone/>
+            </a:pPr>
+            <a:r>
+              <a:rPr lang="en-US" sz="950" dirty="0">
+                <a:solidFill>
+                  <a:srgbClr val="F5F4EF"/>
+                </a:solidFill>
+                <a:latin typeface="DM Sans" pitchFamily="34" charset="0"/>
+                <a:ea typeface="DM Sans" pitchFamily="34" charset="-122"/>
+                <a:cs typeface="DM Sans" pitchFamily="34" charset="-120"/>
+              </a:rPr>
+              <a:t>•</a:t>
+            </a:r>
+            <a:endParaRPr lang="en-US" sz="950" dirty="0"/>
+          </a:p>
+        </p:txBody>
+      </p:sp>
+      <p:sp>
+        <p:nvSpPr>
+          <p:cNvPr id="13" name="Text 9"/>
+          <p:cNvSpPr/>
+          <p:nvPr/>
+        </p:nvSpPr>
+        <p:spPr>
+          <a:xfrm>
+            <a:off x="714375" y="3795117"/>
+            <a:ext cx="46434" cy="192881"/>
+          </a:xfrm>
+          <a:prstGeom prst="rect">
+            <a:avLst/>
+          </a:prstGeom>
+          <a:noFill/>
+          <a:ln/>
+        </p:spPr>
+        <p:txBody>
+          <a:bodyPr wrap="none" lIns="0" tIns="0" rIns="0" bIns="0" rtlCol="0" anchor="t">
+            <a:spAutoFit/>
+          </a:bodyPr>
+          <a:lstStyle/>
+          <a:p>
+            <a:pPr marL="0" indent="0" algn="l">
+              <a:lnSpc>
+                <a:spcPct val="120000"/>
+              </a:lnSpc>
+              <a:buNone/>
+            </a:pPr>
+            <a:r>
+              <a:rPr lang="en-US" sz="950" dirty="0">
+                <a:solidFill>
+                  <a:srgbClr val="F5F4EF"/>
+                </a:solidFill>
+                <a:latin typeface="DM Sans" pitchFamily="34" charset="0"/>
+                <a:ea typeface="DM Sans" pitchFamily="34" charset="-122"/>
+                <a:cs typeface="DM Sans" pitchFamily="34" charset="-120"/>
+              </a:rPr>
+              <a:t>•</a:t>
+            </a:r>
+            <a:endParaRPr lang="en-US" sz="950" dirty="0"/>
+          </a:p>
+        </p:txBody>
+      </p:sp>
+      <p:sp>
+        <p:nvSpPr>
+          <p:cNvPr id="14" name="Text 10"/>
+          <p:cNvSpPr/>
+          <p:nvPr/>
+        </p:nvSpPr>
+        <p:spPr>
+          <a:xfrm>
+            <a:off x="714375" y="4095155"/>
+            <a:ext cx="46434" cy="192881"/>
+          </a:xfrm>
+          <a:prstGeom prst="rect">
+            <a:avLst/>
+          </a:prstGeom>
+          <a:noFill/>
+          <a:ln/>
+        </p:spPr>
+        <p:txBody>
+          <a:bodyPr wrap="none" lIns="0" tIns="0" rIns="0" bIns="0" rtlCol="0" anchor="t">
+            <a:spAutoFit/>
+          </a:bodyPr>
+          <a:lstStyle/>
+          <a:p>
+            <a:pPr marL="0" indent="0" algn="l">
+              <a:lnSpc>
+                <a:spcPct val="120000"/>
+              </a:lnSpc>
+              <a:buNone/>
+            </a:pPr>
+            <a:r>
+              <a:rPr lang="en-US" sz="950" dirty="0">
+                <a:solidFill>
+                  <a:srgbClr val="F5F4EF"/>
+                </a:solidFill>
+                <a:latin typeface="DM Sans" pitchFamily="34" charset="0"/>
+                <a:ea typeface="DM Sans" pitchFamily="34" charset="-122"/>
+                <a:cs typeface="DM Sans" pitchFamily="34" charset="-120"/>
+              </a:rPr>
+              <a:t>•</a:t>
+            </a:r>
+            <a:endParaRPr lang="en-US" sz="950" dirty="0"/>
+          </a:p>
+        </p:txBody>
+      </p:sp>
+      <p:sp>
+        <p:nvSpPr>
+          <p:cNvPr id="15" name="Text 11"/>
+          <p:cNvSpPr/>
+          <p:nvPr/>
+        </p:nvSpPr>
+        <p:spPr>
+          <a:xfrm>
+            <a:off x="714375" y="4588073"/>
+            <a:ext cx="46434" cy="192881"/>
+          </a:xfrm>
+          <a:prstGeom prst="rect">
+            <a:avLst/>
+          </a:prstGeom>
+          <a:noFill/>
+          <a:ln/>
+        </p:spPr>
+        <p:txBody>
+          <a:bodyPr wrap="none" lIns="0" tIns="0" rIns="0" bIns="0" rtlCol="0" anchor="t">
+            <a:spAutoFit/>
+          </a:bodyPr>
+          <a:lstStyle/>
+          <a:p>
+            <a:pPr marL="0" indent="0" algn="l">
+              <a:lnSpc>
+                <a:spcPct val="120000"/>
+              </a:lnSpc>
+              <a:buNone/>
+            </a:pPr>
+            <a:r>
+              <a:rPr lang="en-US" sz="950" dirty="0">
+                <a:solidFill>
+                  <a:srgbClr val="F5F4EF"/>
+                </a:solidFill>
+                <a:latin typeface="DM Sans" pitchFamily="34" charset="0"/>
+                <a:ea typeface="DM Sans" pitchFamily="34" charset="-122"/>
+                <a:cs typeface="DM Sans" pitchFamily="34" charset="-120"/>
+              </a:rPr>
+              <a:t>•</a:t>
+            </a:r>
+            <a:endParaRPr lang="en-US" sz="950" dirty="0"/>
+          </a:p>
+        </p:txBody>
+      </p:sp>
+      <p:pic>
+        <p:nvPicPr>
+          <p:cNvPr id="16" name="Image 2" descr="preencoded.png"/>
+          <p:cNvPicPr>
+            <a:picLocks noChangeAspect="1"/>
+          </p:cNvPicPr>
+          <p:nvPr/>
+        </p:nvPicPr>
+        <p:blipFill>
+          <a:blip r:embed="rId5"/>
+          <a:stretch>
+            <a:fillRect/>
+          </a:stretch>
+        </p:blipFill>
+        <p:spPr>
+          <a:xfrm>
+            <a:off x="4786313" y="1918097"/>
+            <a:ext cx="642938" cy="642938"/>
+          </a:xfrm>
+          <a:prstGeom prst="rect">
+            <a:avLst/>
+          </a:prstGeom>
+        </p:spPr>
+      </p:pic>
+      <p:sp>
+        <p:nvSpPr>
+          <p:cNvPr id="17" name="Text 12"/>
+          <p:cNvSpPr/>
+          <p:nvPr/>
+        </p:nvSpPr>
+        <p:spPr>
+          <a:xfrm>
+            <a:off x="4786313" y="2811066"/>
+            <a:ext cx="3643313" cy="248245"/>
+          </a:xfrm>
+          <a:prstGeom prst="rect">
+            <a:avLst/>
+          </a:prstGeom>
+          <a:noFill/>
+          <a:ln/>
+        </p:spPr>
+        <p:txBody>
+          <a:bodyPr wrap="square" lIns="0" tIns="0" rIns="0" bIns="0" rtlCol="0" anchor="t">
+            <a:spAutoFit/>
+          </a:bodyPr>
+          <a:lstStyle/>
+          <a:p>
+            <a:pPr marL="0" indent="0" algn="l">
+              <a:buNone/>
+            </a:pPr>
+            <a:r>
+              <a:rPr lang="en-US" sz="1500" dirty="0">
+                <a:solidFill>
+                  <a:srgbClr val="378ADD"/>
+                </a:solidFill>
+                <a:latin typeface="Fraunces" pitchFamily="34" charset="0"/>
+                <a:ea typeface="Fraunces" pitchFamily="34" charset="-122"/>
+                <a:cs typeface="Fraunces" pitchFamily="34" charset="-120"/>
+              </a:rPr>
+              <a:t>iMessage &amp; SMS for AI Agents</a:t>
+            </a:r>
+            <a:endParaRPr lang="en-US" sz="1500" dirty="0"/>
+          </a:p>
+        </p:txBody>
+      </p:sp>
+      <p:sp>
+        <p:nvSpPr>
+          <p:cNvPr id="18" name="Text 13"/>
+          <p:cNvSpPr/>
+          <p:nvPr/>
+        </p:nvSpPr>
+        <p:spPr>
+          <a:xfrm>
+            <a:off x="4786313" y="3130748"/>
+            <a:ext cx="3643313" cy="185738"/>
+          </a:xfrm>
+          <a:prstGeom prst="rect">
+            <a:avLst/>
+          </a:prstGeom>
+          <a:noFill/>
+          <a:ln/>
+        </p:spPr>
+        <p:txBody>
+          <a:bodyPr wrap="square" lIns="127508" tIns="0" rIns="0" bIns="0" rtlCol="0" anchor="t">
+            <a:spAutoFit/>
+          </a:bodyPr>
+          <a:lstStyle/>
+          <a:p>
+            <a:pPr marL="0" indent="0" algn="l">
+              <a:buNone/>
+            </a:pPr>
+            <a:r>
+              <a:rPr lang="en-US" sz="1050" i="1" dirty="0">
+                <a:solidFill>
+                  <a:srgbClr val="F5F4EF"/>
+                </a:solidFill>
+                <a:latin typeface="DM Sans" pitchFamily="34" charset="0"/>
+                <a:ea typeface="DM Sans" pitchFamily="34" charset="-122"/>
+                <a:cs typeface="DM Sans" pitchFamily="34" charset="-120"/>
+              </a:rPr>
+              <a:t>"The same infrastructure that powers Poke."</a:t>
+            </a:r>
+            <a:endParaRPr lang="en-US" sz="1050" dirty="0"/>
+          </a:p>
+        </p:txBody>
+      </p:sp>
+      <p:sp>
+        <p:nvSpPr>
+          <p:cNvPr id="19" name="Text 14"/>
+          <p:cNvSpPr/>
+          <p:nvPr/>
+        </p:nvSpPr>
+        <p:spPr>
+          <a:xfrm>
+            <a:off x="4786313" y="3495080"/>
+            <a:ext cx="3643313" cy="192881"/>
+          </a:xfrm>
+          <a:prstGeom prst="rect">
+            <a:avLst/>
+          </a:prstGeom>
+          <a:noFill/>
+          <a:ln/>
+        </p:spPr>
+        <p:txBody>
+          <a:bodyPr wrap="none" lIns="170053" tIns="0" rIns="0" bIns="0" rtlCol="0" anchor="t">
+            <a:spAutoFit/>
+          </a:bodyPr>
+          <a:lstStyle/>
+          <a:p>
+            <a:pPr marL="0" indent="0" algn="l">
+              <a:lnSpc>
+                <a:spcPct val="120000"/>
+              </a:lnSpc>
+              <a:buNone/>
+            </a:pPr>
+            <a:r>
+              <a:rPr lang="en-US" sz="900" b="1" dirty="0">
+                <a:solidFill>
+                  <a:srgbClr val="A5A39A"/>
+                </a:solidFill>
+                <a:latin typeface="DM Sans Bold" pitchFamily="34" charset="0"/>
+                <a:ea typeface="DM Sans Bold" pitchFamily="34" charset="-122"/>
+                <a:cs typeface="DM Sans Bold" pitchFamily="34" charset="-120"/>
+              </a:rPr>
+              <a:t>Native iMessage</a:t>
+            </a:r>
+            <a:r>
+              <a:rPr lang="en-US" sz="950" dirty="0">
+                <a:solidFill>
+                  <a:srgbClr val="A5A39A"/>
+                </a:solidFill>
+                <a:latin typeface="DM Sans" pitchFamily="34" charset="0"/>
+                <a:ea typeface="DM Sans" pitchFamily="34" charset="-122"/>
+                <a:cs typeface="DM Sans" pitchFamily="34" charset="-120"/>
+              </a:rPr>
+              <a:t>, RCS, and SMS delivery</a:t>
+            </a:r>
+            <a:endParaRPr lang="en-US" sz="900" dirty="0"/>
+          </a:p>
+        </p:txBody>
+      </p:sp>
+      <p:sp>
+        <p:nvSpPr>
+          <p:cNvPr id="20" name="Text 15"/>
+          <p:cNvSpPr/>
+          <p:nvPr/>
+        </p:nvSpPr>
+        <p:spPr>
+          <a:xfrm>
+            <a:off x="4786313" y="3795117"/>
+            <a:ext cx="3643313" cy="192881"/>
+          </a:xfrm>
+          <a:prstGeom prst="rect">
+            <a:avLst/>
+          </a:prstGeom>
+          <a:noFill/>
+          <a:ln/>
+        </p:spPr>
+        <p:txBody>
+          <a:bodyPr wrap="none" lIns="170053" tIns="0" rIns="0" bIns="0" rtlCol="0" anchor="t">
+            <a:spAutoFit/>
+          </a:bodyPr>
+          <a:lstStyle/>
+          <a:p>
+            <a:pPr marL="0" indent="0" algn="l">
+              <a:lnSpc>
+                <a:spcPct val="120000"/>
+              </a:lnSpc>
+              <a:buNone/>
+            </a:pPr>
+            <a:r>
+              <a:rPr lang="en-US" sz="950" dirty="0">
+                <a:solidFill>
+                  <a:srgbClr val="A5A39A"/>
+                </a:solidFill>
+                <a:latin typeface="DM Sans" pitchFamily="34" charset="0"/>
+                <a:ea typeface="DM Sans" pitchFamily="34" charset="-122"/>
+                <a:cs typeface="DM Sans" pitchFamily="34" charset="-120"/>
+              </a:rPr>
+              <a:t>Trusted by </a:t>
+            </a:r>
+            <a:r>
+              <a:rPr lang="en-US" sz="900" b="1" dirty="0">
+                <a:solidFill>
+                  <a:srgbClr val="A5A39A"/>
+                </a:solidFill>
+                <a:latin typeface="DM Sans Bold" pitchFamily="34" charset="0"/>
+                <a:ea typeface="DM Sans Bold" pitchFamily="34" charset="-122"/>
+                <a:cs typeface="DM Sans Bold" pitchFamily="34" charset="-120"/>
+              </a:rPr>
+              <a:t>50,000+ teams</a:t>
+            </a:r>
+            <a:r>
+              <a:rPr lang="en-US" sz="950" dirty="0">
+                <a:solidFill>
+                  <a:srgbClr val="A5A39A"/>
+                </a:solidFill>
+                <a:latin typeface="DM Sans" pitchFamily="34" charset="0"/>
+                <a:ea typeface="DM Sans" pitchFamily="34" charset="-122"/>
+                <a:cs typeface="DM Sans" pitchFamily="34" charset="-120"/>
+              </a:rPr>
+              <a:t> on Linq Blue</a:t>
+            </a:r>
+            <a:endParaRPr lang="en-US" sz="950" dirty="0"/>
+          </a:p>
+        </p:txBody>
+      </p:sp>
+      <p:sp>
+        <p:nvSpPr>
+          <p:cNvPr id="21" name="Text 16"/>
+          <p:cNvSpPr/>
+          <p:nvPr/>
+        </p:nvSpPr>
+        <p:spPr>
+          <a:xfrm>
+            <a:off x="4786313" y="4095155"/>
+            <a:ext cx="3643313" cy="385763"/>
+          </a:xfrm>
+          <a:prstGeom prst="rect">
+            <a:avLst/>
+          </a:prstGeom>
+          <a:noFill/>
+          <a:ln/>
+        </p:spPr>
+        <p:txBody>
+          <a:bodyPr wrap="square" lIns="170053" tIns="0" rIns="0" bIns="0" rtlCol="0" anchor="t">
+            <a:spAutoFit/>
+          </a:bodyPr>
+          <a:lstStyle/>
+          <a:p>
+            <a:pPr marL="0" indent="0" algn="l">
+              <a:lnSpc>
+                <a:spcPct val="120000"/>
+              </a:lnSpc>
+              <a:buNone/>
+            </a:pPr>
+            <a:r>
+              <a:rPr lang="en-US" sz="950" dirty="0">
+                <a:solidFill>
+                  <a:srgbClr val="A5A39A"/>
+                </a:solidFill>
+                <a:latin typeface="DM Sans" pitchFamily="34" charset="0"/>
+                <a:ea typeface="DM Sans" pitchFamily="34" charset="-122"/>
+                <a:cs typeface="DM Sans" pitchFamily="34" charset="-120"/>
+              </a:rPr>
               <a:t>Read receipts, voice notes, and tapbacks supported natively</a:t>
             </a:r>
             <a:endParaRPr lang="en-US" sz="950" dirty="0"/>
@@ -3400,7 +3187,7 @@
           </a:bodyPr>
           <a:lstStyle/>
           <a:p>
-            <a:pPr algn="l" indent="0" marL="0">
+            <a:pPr marL="0" indent="0" algn="l">
               <a:lnSpc>
                 <a:spcPct val="120000"/>
               </a:lnSpc>
@@ -3442,6 +3229,13 @@
           </a:solidFill>
           <a:ln/>
         </p:spPr>
+        <p:txBody>
+          <a:bodyPr/>
+          <a:lstStyle/>
+          <a:p>
+            <a:endParaRPr lang="en-US"/>
+          </a:p>
+        </p:txBody>
       </p:sp>
       <p:sp>
         <p:nvSpPr>
@@ -3462,6 +3256,13 @@
           </a:solidFill>
           <a:ln/>
         </p:spPr>
+        <p:txBody>
+          <a:bodyPr/>
+          <a:lstStyle/>
+          <a:p>
+            <a:endParaRPr lang="en-US"/>
+          </a:p>
+        </p:txBody>
       </p:sp>
       <p:sp>
         <p:nvSpPr>
@@ -3486,7 +3287,7 @@
           </a:bodyPr>
           <a:lstStyle/>
           <a:p>
-            <a:pPr algn="ctr" indent="0" marL="0">
+            <a:pPr marL="0" indent="0" algn="ctr">
               <a:buNone/>
             </a:pPr>
             <a:r>
@@ -3527,7 +3328,7 @@
           </a:bodyPr>
           <a:lstStyle/>
           <a:p>
-            <a:pPr algn="l" indent="0" marL="0">
+            <a:pPr marL="0" indent="0" algn="l">
               <a:lnSpc>
                 <a:spcPct val="120000"/>
               </a:lnSpc>
@@ -3571,7 +3372,7 @@
           </a:bodyPr>
           <a:lstStyle/>
           <a:p>
-            <a:pPr algn="l" indent="0" marL="0">
+            <a:pPr marL="0" indent="0" algn="l">
               <a:lnSpc>
                 <a:spcPct val="120000"/>
               </a:lnSpc>
@@ -3615,7 +3416,7 @@
           </a:bodyPr>
           <a:lstStyle/>
           <a:p>
-            <a:pPr algn="l" indent="0" marL="0">
+            <a:pPr marL="0" indent="0" algn="l">
               <a:lnSpc>
                 <a:spcPct val="120000"/>
               </a:lnSpc>
@@ -3659,7 +3460,7 @@
           </a:bodyPr>
           <a:lstStyle/>
           <a:p>
-            <a:pPr algn="l" indent="0" marL="0">
+            <a:pPr marL="0" indent="0" algn="l">
               <a:lnSpc>
                 <a:spcPct val="120000"/>
               </a:lnSpc>
@@ -3981,4 +3782,319 @@
     </a:ext>
   </a:extLst>
 </a:theme>
+</file>
+
+<file path=ppt/theme/theme2.xml><?xml version="1.0" encoding="utf-8"?>
+<a:theme xmlns:a="http://schemas.openxmlformats.org/drawingml/2006/main" name="Office Theme">
+  <a:themeElements>
+    <a:clrScheme name="Office">
+      <a:dk1>
+        <a:sysClr val="windowText" lastClr="000000"/>
+      </a:dk1>
+      <a:lt1>
+        <a:sysClr val="window" lastClr="FFFFFF"/>
+      </a:lt1>
+      <a:dk2>
+        <a:srgbClr val="0E2841"/>
+      </a:dk2>
+      <a:lt2>
+        <a:srgbClr val="E8E8E8"/>
+      </a:lt2>
+      <a:accent1>
+        <a:srgbClr val="156082"/>
+      </a:accent1>
+      <a:accent2>
+        <a:srgbClr val="E97132"/>
+      </a:accent2>
+      <a:accent3>
+        <a:srgbClr val="196B24"/>
+      </a:accent3>
+      <a:accent4>
+        <a:srgbClr val="0F9ED5"/>
+      </a:accent4>
+      <a:accent5>
+        <a:srgbClr val="A02B93"/>
+      </a:accent5>
+      <a:accent6>
+        <a:srgbClr val="4EA72E"/>
+      </a:accent6>
+      <a:hlink>
+        <a:srgbClr val="467886"/>
+      </a:hlink>
+      <a:folHlink>
+        <a:srgbClr val="96607D"/>
+      </a:folHlink>
+    </a:clrScheme>
+    <a:fontScheme name="Office">
+      <a:majorFont>
+        <a:latin typeface="Aptos Display" panose="02110004020202020204"/>
+        <a:ea typeface=""/>
+        <a:cs typeface=""/>
+        <a:font script="Jpan" typeface="游ゴシック Light"/>
+        <a:font script="Hang" typeface="맑은 고딕"/>
+        <a:font script="Hans" typeface="等线 Light"/>
+        <a:font script="Hant" typeface="新細明體"/>
+        <a:font script="Arab" typeface="Times New Roman"/>
+        <a:font script="Hebr" typeface="Times New Roman"/>
+        <a:font script="Thai" typeface="Angsana New"/>
+        <a:font script="Ethi" typeface="Nyala"/>
+        <a:font script="Beng" typeface="Vrinda"/>
+        <a:font script="Gujr" typeface="Shruti"/>
+        <a:font script="Khmr" typeface="MoolBoran"/>
+        <a:font script="Knda" typeface="Tunga"/>
+        <a:font script="Guru" typeface="Raavi"/>
+        <a:font script="Cans" typeface="Euphemia"/>
+        <a:font script="Cher" typeface="Plantagenet Cherokee"/>
+        <a:font script="Yiii" typeface="Microsoft Yi Baiti"/>
+        <a:font script="Tibt" typeface="Microsoft Himalaya"/>
+        <a:font script="Thaa" typeface="MV Boli"/>
+        <a:font script="Deva" typeface="Mangal"/>
+        <a:font script="Telu" typeface="Gautami"/>
+        <a:font script="Taml" typeface="Latha"/>
+        <a:font script="Syrc" typeface="Estrangelo Edessa"/>
+        <a:font script="Orya" typeface="Kalinga"/>
+        <a:font script="Mlym" typeface="Kartika"/>
+        <a:font script="Laoo" typeface="DokChampa"/>
+        <a:font script="Sinh" typeface="Iskoola Pota"/>
+        <a:font script="Mong" typeface="Mongolian Baiti"/>
+        <a:font script="Viet" typeface="Times New Roman"/>
+        <a:font script="Uigh" typeface="Microsoft Uighur"/>
+        <a:font script="Geor" typeface="Sylfaen"/>
+        <a:font script="Armn" typeface="Arial"/>
+        <a:font script="Bugi" typeface="Leelawadee UI"/>
+        <a:font script="Bopo" typeface="Microsoft JhengHei"/>
+        <a:font script="Java" typeface="Javanese Text"/>
+        <a:font script="Lisu" typeface="Segoe UI"/>
+        <a:font script="Mymr" typeface="Myanmar Text"/>
+        <a:font script="Nkoo" typeface="Ebrima"/>
+        <a:font script="Olck" typeface="Nirmala UI"/>
+        <a:font script="Osma" typeface="Ebrima"/>
+        <a:font script="Phag" typeface="Phagspa"/>
+        <a:font script="Syrn" typeface="Estrangelo Edessa"/>
+        <a:font script="Syrj" typeface="Estrangelo Edessa"/>
+        <a:font script="Syre" typeface="Estrangelo Edessa"/>
+        <a:font script="Sora" typeface="Nirmala UI"/>
+        <a:font script="Tale" typeface="Microsoft Tai Le"/>
+        <a:font script="Talu" typeface="Microsoft New Tai Lue"/>
+        <a:font script="Tfng" typeface="Ebrima"/>
+      </a:majorFont>
+      <a:minorFont>
+        <a:latin typeface="Aptos" panose="02110004020202020204"/>
+        <a:ea typeface=""/>
+        <a:cs typeface=""/>
+        <a:font script="Jpan" typeface="游ゴシック"/>
+        <a:font script="Hang" typeface="맑은 고딕"/>
+        <a:font script="Hans" typeface="等线"/>
+        <a:font script="Hant" typeface="新細明體"/>
+        <a:font script="Arab" typeface="Arial"/>
+        <a:font script="Hebr" typeface="Arial"/>
+        <a:font script="Thai" typeface="Cordia New"/>
+        <a:font script="Ethi" typeface="Nyala"/>
+        <a:font script="Beng" typeface="Vrinda"/>
+        <a:font script="Gujr" typeface="Shruti"/>
+        <a:font script="Khmr" typeface="DaunPenh"/>
+        <a:font script="Knda" typeface="Tunga"/>
+        <a:font script="Guru" typeface="Raavi"/>
+        <a:font script="Cans" typeface="Euphemia"/>
+        <a:font script="Cher" typeface="Plantagenet Cherokee"/>
+        <a:font script="Yiii" typeface="Microsoft Yi Baiti"/>
+        <a:font script="Tibt" typeface="Microsoft Himalaya"/>
+        <a:font script="Thaa" typeface="MV Boli"/>
+        <a:font script="Deva" typeface="Mangal"/>
+        <a:font script="Telu" typeface="Gautami"/>
+        <a:font script="Taml" typeface="Latha"/>
+        <a:font script="Syrc" typeface="Estrangelo Edessa"/>
+        <a:font script="Orya" typeface="Kalinga"/>
+        <a:font script="Mlym" typeface="Kartika"/>
+        <a:font script="Laoo" typeface="DokChampa"/>
+        <a:font script="Sinh" typeface="Iskoola Pota"/>
+        <a:font script="Mong" typeface="Mongolian Baiti"/>
+        <a:font script="Viet" typeface="Arial"/>
+        <a:font script="Uigh" typeface="Microsoft Uighur"/>
+        <a:font script="Geor" typeface="Sylfaen"/>
+        <a:font script="Armn" typeface="Arial"/>
+        <a:font script="Bugi" typeface="Leelawadee UI"/>
+        <a:font script="Bopo" typeface="Microsoft JhengHei"/>
+        <a:font script="Java" typeface="Javanese Text"/>
+        <a:font script="Lisu" typeface="Segoe UI"/>
+        <a:font script="Mymr" typeface="Myanmar Text"/>
+        <a:font script="Nkoo" typeface="Ebrima"/>
+        <a:font script="Olck" typeface="Nirmala UI"/>
+        <a:font script="Osma" typeface="Ebrima"/>
+        <a:font script="Phag" typeface="Phagspa"/>
+        <a:font script="Syrn" typeface="Estrangelo Edessa"/>
+        <a:font script="Syrj" typeface="Estrangelo Edessa"/>
+        <a:font script="Syre" typeface="Estrangelo Edessa"/>
+        <a:font script="Sora" typeface="Nirmala UI"/>
+        <a:font script="Tale" typeface="Microsoft Tai Le"/>
+        <a:font script="Talu" typeface="Microsoft New Tai Lue"/>
+        <a:font script="Tfng" typeface="Ebrima"/>
+      </a:minorFont>
+    </a:fontScheme>
+    <a:fmtScheme name="Office">
+      <a:fillStyleLst>
+        <a:solidFill>
+          <a:schemeClr val="phClr"/>
+        </a:solidFill>
+        <a:gradFill rotWithShape="1">
+          <a:gsLst>
+            <a:gs pos="0">
+              <a:schemeClr val="phClr">
+                <a:lumMod val="110000"/>
+                <a:satMod val="105000"/>
+                <a:tint val="67000"/>
+              </a:schemeClr>
+            </a:gs>
+            <a:gs pos="50000">
+              <a:schemeClr val="phClr">
+                <a:lumMod val="105000"/>
+                <a:satMod val="103000"/>
+                <a:tint val="73000"/>
+              </a:schemeClr>
+            </a:gs>
+            <a:gs pos="100000">
+              <a:schemeClr val="phClr">
+                <a:lumMod val="105000"/>
+                <a:satMod val="109000"/>
+                <a:tint val="81000"/>
+              </a:schemeClr>
+            </a:gs>
+          </a:gsLst>
+          <a:lin ang="5400000" scaled="0"/>
+        </a:gradFill>
+        <a:gradFill rotWithShape="1">
+          <a:gsLst>
+            <a:gs pos="0">
+              <a:schemeClr val="phClr">
+                <a:satMod val="103000"/>
+                <a:lumMod val="102000"/>
+                <a:tint val="94000"/>
+              </a:schemeClr>
+            </a:gs>
+            <a:gs pos="50000">
+              <a:schemeClr val="phClr">
+                <a:satMod val="110000"/>
+                <a:lumMod val="100000"/>
+                <a:shade val="100000"/>
+              </a:schemeClr>
+            </a:gs>
+            <a:gs pos="100000">
+              <a:schemeClr val="phClr">
+                <a:lumMod val="99000"/>
+                <a:satMod val="120000"/>
+                <a:shade val="78000"/>
+              </a:schemeClr>
+            </a:gs>
+          </a:gsLst>
+          <a:lin ang="5400000" scaled="0"/>
+        </a:gradFill>
+      </a:fillStyleLst>
+      <a:lnStyleLst>
+        <a:ln w="12700" cap="flat" cmpd="sng" algn="ctr">
+          <a:solidFill>
+            <a:schemeClr val="phClr"/>
+          </a:solidFill>
+          <a:prstDash val="solid"/>
+          <a:miter lim="800000"/>
+        </a:ln>
+        <a:ln w="19050" cap="flat" cmpd="sng" algn="ctr">
+          <a:solidFill>
+            <a:schemeClr val="phClr"/>
+          </a:solidFill>
+          <a:prstDash val="solid"/>
+          <a:miter lim="800000"/>
+        </a:ln>
+        <a:ln w="25400" cap="flat" cmpd="sng" algn="ctr">
+          <a:solidFill>
+            <a:schemeClr val="phClr"/>
+          </a:solidFill>
+          <a:prstDash val="solid"/>
+          <a:miter lim="800000"/>
+        </a:ln>
+      </a:lnStyleLst>
+      <a:effectStyleLst>
+        <a:effectStyle>
+          <a:effectLst/>
+        </a:effectStyle>
+        <a:effectStyle>
+          <a:effectLst/>
+        </a:effectStyle>
+        <a:effectStyle>
+          <a:effectLst>
+            <a:outerShdw blurRad="57150" dist="19050" dir="5400000" algn="ctr" rotWithShape="0">
+              <a:srgbClr val="000000">
+                <a:alpha val="63000"/>
+              </a:srgbClr>
+            </a:outerShdw>
+          </a:effectLst>
+        </a:effectStyle>
+      </a:effectStyleLst>
+      <a:bgFillStyleLst>
+        <a:solidFill>
+          <a:schemeClr val="phClr"/>
+        </a:solidFill>
+        <a:solidFill>
+          <a:schemeClr val="phClr">
+            <a:tint val="95000"/>
+            <a:satMod val="170000"/>
+          </a:schemeClr>
+        </a:solidFill>
+        <a:gradFill rotWithShape="1">
+          <a:gsLst>
+            <a:gs pos="0">
+              <a:schemeClr val="phClr">
+                <a:tint val="93000"/>
+                <a:satMod val="150000"/>
+                <a:shade val="98000"/>
+                <a:lumMod val="102000"/>
+              </a:schemeClr>
+            </a:gs>
+            <a:gs pos="50000">
+              <a:schemeClr val="phClr">
+                <a:tint val="98000"/>
+                <a:satMod val="130000"/>
+                <a:shade val="90000"/>
+                <a:lumMod val="103000"/>
+              </a:schemeClr>
+            </a:gs>
+            <a:gs pos="100000">
+              <a:schemeClr val="phClr">
+                <a:shade val="63000"/>
+                <a:satMod val="120000"/>
+              </a:schemeClr>
+            </a:gs>
+          </a:gsLst>
+          <a:lin ang="5400000" scaled="0"/>
+        </a:gradFill>
+      </a:bgFillStyleLst>
+    </a:fmtScheme>
+  </a:themeElements>
+  <a:objectDefaults>
+    <a:lnDef>
+      <a:spPr/>
+      <a:bodyPr/>
+      <a:lstStyle/>
+      <a:style>
+        <a:lnRef idx="2">
+          <a:schemeClr val="accent1"/>
+        </a:lnRef>
+        <a:fillRef idx="0">
+          <a:schemeClr val="accent1"/>
+        </a:fillRef>
+        <a:effectRef idx="1">
+          <a:schemeClr val="accent1"/>
+        </a:effectRef>
+        <a:fontRef idx="minor">
+          <a:schemeClr val="tx1"/>
+        </a:fontRef>
+      </a:style>
+    </a:lnDef>
+  </a:objectDefaults>
+  <a:extraClrSchemeLst/>
+  <a:extLst>
+    <a:ext uri="{05A4C25C-085E-4340-85A3-A5531E510DB2}">
+      <thm15:themeFamily xmlns:thm15="http://schemas.microsoft.com/office/thememl/2012/main" name="Office Theme" id="{2E142A2C-CD16-42D6-873A-C26D2A0506FA}" vid="{1BDDFF52-6CD6-40A5-AB3C-68EB2F1E4D0A}"/>
+    </a:ext>
+  </a:extLst>
+</a:theme>
 </file>
</xml_diff>